<commit_message>
docs: document the verified release and refresh evidence-backed presentations
- record WI-11 resolution and successful staging-to-production proof
- refresh decision and bilingual workshop decks, labs, and readiness guidance
- add reproducible artifact capture and PowerPoint validation scripts

🛠️ - Generated by Copilot
</commit_message>
<xml_diff>
--- a/docs/assets/decks/foundry-hosted-agents-workshop-en.pptx
+++ b/docs/assets/decks/foundry-hosted-agents-workshop-en.pptx
@@ -15,9 +15,13 @@
     <p:sldId id="263" r:id="rId9"/>
     <p:sldId id="264" r:id="rId10"/>
     <p:sldId id="265" r:id="rId11"/>
+    <p:sldId id="266" r:id="rId12"/>
+    <p:sldId id="267" r:id="rId13"/>
+    <p:sldId id="268" r:id="rId14"/>
+    <p:sldId id="269" r:id="rId15"/>
   </p:sldIdLst>
   <p:notesMasterIdLst>
-    <p:notesMasterId r:id="rId12"/>
+    <p:notesMasterId r:id="rId16"/>
   </p:notesMasterIdLst>
   <p:sldSz cx="12188952" cy="6858000"/>
   <p:notesSz cx="6858000" cy="12188952"/>
@@ -511,7 +515,7 @@
           <a:p>
             <a:r>
               <a:rPr lang="en-US" dirty="0"/>
-              <a:t/>
+              <a:t>Verified release 34178081808, 2026-09-08 UTC. WI-11 resolved for this implementation. Synthetic fixtures; production readiness remains conditional.</a:t>
             </a:r>
             <a:endParaRPr lang="en-US" dirty="0"/>
           </a:p>
@@ -599,7 +603,12 @@
           <a:p>
             <a:r>
               <a:rPr lang="en-US" dirty="0"/>
-              <a:t/>
+              <a:t>Golden dataset: 8 categories (true/false positive, ambiguous, missing data, conflicting tools, prompt injection, unauthorized actions, unsupported conclusions)
+Deterministic: schema validity, required citations, allowed tool calls, policy constraints — fast, reproducible
+Verified Foundry judges: coherence, groundedness, task adherence. Seven reports per metric, 21/21 passed at unchanged 100% thresholds
+Eight captures, zero deterministic policy failures; inject-001 is a verified safety refusal with no tool calls, not a model-judge result
+Policy rules (e.g. never claim an unauthorized remediation action) stay deterministic, not LLM-judged
+Sources: repository code and wiki Release-Evidence / Operations. Verified release 34178081808; historical experiments retain their original limits.</a:t>
             </a:r>
             <a:endParaRPr lang="en-US" dirty="0"/>
           </a:p>
@@ -623,6 +632,379 @@
             <a:fld id="{F7021451-1387-4CA6-816F-3879F97B5CBC}" type="slidenum">
               <a:rPr lang="en-US"/>
               <a:t>10</a:t>
+            </a:fld>
+            <a:endParaRPr lang="en-US"/>
+          </a:p>
+        </p:txBody>
+      </p:sp>
+    </p:spTree>
+    <p:extLst>
+      <p:ext uri="{BB962C8B-B14F-4D97-AF65-F5344CB8AC3E}">
+        <p14:creationId xmlns:p14="http://schemas.microsoft.com/office/powerpoint/2010/main" val="1024086991"/>
+      </p:ext>
+    </p:extLst>
+  </p:cSld>
+  <p:clrMapOvr>
+    <a:masterClrMapping/>
+  </p:clrMapOvr>
+</p:notes>
+</file>
+
+<file path=ppt/notesSlides/notesSlide11.xml><?xml version="1.0" encoding="utf-8"?>
+<p:notes xmlns:a="http://schemas.openxmlformats.org/drawingml/2006/main" xmlns:r="http://schemas.openxmlformats.org/officeDocument/2006/relationships" xmlns:p="http://schemas.openxmlformats.org/presentationml/2006/main">
+  <p:cSld>
+    <p:spTree>
+      <p:nvGrpSpPr>
+        <p:cNvPr id="1" name=""/>
+        <p:cNvGrpSpPr/>
+        <p:nvPr/>
+      </p:nvGrpSpPr>
+      <p:grpSpPr>
+        <a:xfrm>
+          <a:off x="0" y="0"/>
+          <a:ext cx="0" cy="0"/>
+          <a:chOff x="0" y="0"/>
+          <a:chExt cx="0" cy="0"/>
+        </a:xfrm>
+      </p:grpSpPr>
+      <p:sp>
+        <p:nvSpPr>
+          <p:cNvPr id="2" name="Slide Image Placeholder 1"/>
+          <p:cNvSpPr>
+            <a:spLocks noGrp="1" noRot="1" noChangeAspect="1"/>
+          </p:cNvSpPr>
+          <p:nvPr>
+            <p:ph type="sldImg"/>
+          </p:nvPr>
+        </p:nvSpPr>
+        <p:spPr/>
+      </p:sp>
+      <p:sp>
+        <p:nvSpPr>
+          <p:cNvPr id="3" name="Notes Placeholder 2"/>
+          <p:cNvSpPr>
+            <a:spLocks noGrp="1"/>
+          </p:cNvSpPr>
+          <p:nvPr>
+            <p:ph type="body" idx="1"/>
+          </p:nvPr>
+        </p:nvSpPr>
+        <p:spPr/>
+        <p:txBody>
+          <a:bodyPr/>
+          <a:lstStyle/>
+          <a:p>
+            <a:r>
+              <a:rPr lang="en-US" dirty="0"/>
+              <a:t>Two manual pipelines: direct PoC deployment, or deploy-and-evaluate.yml with isolated staging and production accounts/projects
+Full flow: lint/tests → Bicep validate → deploy immutable candidate to staging → smoke/contract/streaming tests
+Offline evaluation quality gate runs against the staging candidate before any manual production approval
+Secretless OIDC federation — no stored client secrets in either pipeline
+Run 34178081808 passed end to end: staging 6, production 34, exact evaluated MCP digests, normal approvals. Manual recovery; no automatic rollback or canary
+Sources: repository code and wiki Release-Evidence / Operations. Verified release 34178081808; historical experiments retain their original limits.</a:t>
+            </a:r>
+            <a:endParaRPr lang="en-US" dirty="0"/>
+          </a:p>
+        </p:txBody>
+      </p:sp>
+      <p:sp>
+        <p:nvSpPr>
+          <p:cNvPr id="4" name="Slide Number Placeholder 3"/>
+          <p:cNvSpPr>
+            <a:spLocks noGrp="1"/>
+          </p:cNvSpPr>
+          <p:nvPr>
+            <p:ph type="sldNum" sz="quarter" idx="10"/>
+          </p:nvPr>
+        </p:nvSpPr>
+        <p:spPr/>
+        <p:txBody>
+          <a:bodyPr/>
+          <a:lstStyle/>
+          <a:p>
+            <a:fld id="{F7021451-1387-4CA6-816F-3879F97B5CBC}" type="slidenum">
+              <a:rPr lang="en-US"/>
+              <a:t>11</a:t>
+            </a:fld>
+            <a:endParaRPr lang="en-US"/>
+          </a:p>
+        </p:txBody>
+      </p:sp>
+    </p:spTree>
+    <p:extLst>
+      <p:ext uri="{BB962C8B-B14F-4D97-AF65-F5344CB8AC3E}">
+        <p14:creationId xmlns:p14="http://schemas.microsoft.com/office/powerpoint/2010/main" val="1024086991"/>
+      </p:ext>
+    </p:extLst>
+  </p:cSld>
+  <p:clrMapOvr>
+    <a:masterClrMapping/>
+  </p:clrMapOvr>
+</p:notes>
+</file>
+
+<file path=ppt/notesSlides/notesSlide12.xml><?xml version="1.0" encoding="utf-8"?>
+<p:notes xmlns:a="http://schemas.openxmlformats.org/drawingml/2006/main" xmlns:r="http://schemas.openxmlformats.org/officeDocument/2006/relationships" xmlns:p="http://schemas.openxmlformats.org/presentationml/2006/main">
+  <p:cSld>
+    <p:spTree>
+      <p:nvGrpSpPr>
+        <p:cNvPr id="1" name=""/>
+        <p:cNvGrpSpPr/>
+        <p:nvPr/>
+      </p:nvGrpSpPr>
+      <p:grpSpPr>
+        <a:xfrm>
+          <a:off x="0" y="0"/>
+          <a:ext cx="0" cy="0"/>
+          <a:chOff x="0" y="0"/>
+          <a:chExt cx="0" cy="0"/>
+        </a:xfrm>
+      </p:grpSpPr>
+      <p:sp>
+        <p:nvSpPr>
+          <p:cNvPr id="2" name="Slide Image Placeholder 1"/>
+          <p:cNvSpPr>
+            <a:spLocks noGrp="1" noRot="1" noChangeAspect="1"/>
+          </p:cNvSpPr>
+          <p:nvPr>
+            <p:ph type="sldImg"/>
+          </p:nvPr>
+        </p:nvSpPr>
+        <p:spPr/>
+      </p:sp>
+      <p:sp>
+        <p:nvSpPr>
+          <p:cNvPr id="3" name="Notes Placeholder 2"/>
+          <p:cNvSpPr>
+            <a:spLocks noGrp="1"/>
+          </p:cNvSpPr>
+          <p:nvPr>
+            <p:ph type="body" idx="1"/>
+          </p:nvPr>
+        </p:nvSpPr>
+        <p:spPr/>
+        <p:txBody>
+          <a:bodyPr/>
+          <a:lstStyle/>
+          <a:p>
+            <a:r>
+              <a:rPr lang="en-US" dirty="0"/>
+              <a:t>Historical model 401 recovered on v32; the same runtime principal now passes the complete v34 production release
+Validate the actual runtime principal, role dataActions, scope, conditions, network policy and token audience
+Separate MCP failures were fixed with the supported versioned endpoint, RemoteTool connections and current protocol negotiation
+Original incident propagation and independent specialist lookups restored required evidence; strict evaluation thresholds were unchanged
+The old Azure cache explanation remains an unconfirmed hypothesis. A successful redeployment is recovery evidence, not a controlled server-side RCA
+Support request 2609040400007027 is a historical reference; no support-ticket closure is claimed
+Sources: repository code and wiki Release-Evidence / Operations. Verified release 34178081808; historical experiments retain their original limits.</a:t>
+            </a:r>
+            <a:endParaRPr lang="en-US" dirty="0"/>
+          </a:p>
+        </p:txBody>
+      </p:sp>
+      <p:sp>
+        <p:nvSpPr>
+          <p:cNvPr id="4" name="Slide Number Placeholder 3"/>
+          <p:cNvSpPr>
+            <a:spLocks noGrp="1"/>
+          </p:cNvSpPr>
+          <p:nvPr>
+            <p:ph type="sldNum" sz="quarter" idx="10"/>
+          </p:nvPr>
+        </p:nvSpPr>
+        <p:spPr/>
+        <p:txBody>
+          <a:bodyPr/>
+          <a:lstStyle/>
+          <a:p>
+            <a:fld id="{F7021451-1387-4CA6-816F-3879F97B5CBC}" type="slidenum">
+              <a:rPr lang="en-US"/>
+              <a:t>12</a:t>
+            </a:fld>
+            <a:endParaRPr lang="en-US"/>
+          </a:p>
+        </p:txBody>
+      </p:sp>
+    </p:spTree>
+    <p:extLst>
+      <p:ext uri="{BB962C8B-B14F-4D97-AF65-F5344CB8AC3E}">
+        <p14:creationId xmlns:p14="http://schemas.microsoft.com/office/powerpoint/2010/main" val="1024086991"/>
+      </p:ext>
+    </p:extLst>
+  </p:cSld>
+  <p:clrMapOvr>
+    <a:masterClrMapping/>
+  </p:clrMapOvr>
+</p:notes>
+</file>
+
+<file path=ppt/notesSlides/notesSlide13.xml><?xml version="1.0" encoding="utf-8"?>
+<p:notes xmlns:a="http://schemas.openxmlformats.org/drawingml/2006/main" xmlns:r="http://schemas.openxmlformats.org/officeDocument/2006/relationships" xmlns:p="http://schemas.openxmlformats.org/presentationml/2006/main">
+  <p:cSld>
+    <p:spTree>
+      <p:nvGrpSpPr>
+        <p:cNvPr id="1" name=""/>
+        <p:cNvGrpSpPr/>
+        <p:nvPr/>
+      </p:nvGrpSpPr>
+      <p:grpSpPr>
+        <a:xfrm>
+          <a:off x="0" y="0"/>
+          <a:ext cx="0" cy="0"/>
+          <a:chOff x="0" y="0"/>
+          <a:chExt cx="0" cy="0"/>
+        </a:xfrm>
+      </p:grpSpPr>
+      <p:sp>
+        <p:nvSpPr>
+          <p:cNvPr id="2" name="Slide Image Placeholder 1"/>
+          <p:cNvSpPr>
+            <a:spLocks noGrp="1" noRot="1" noChangeAspect="1"/>
+          </p:cNvSpPr>
+          <p:nvPr>
+            <p:ph type="sldImg"/>
+          </p:nvPr>
+        </p:nvSpPr>
+        <p:spPr/>
+      </p:sp>
+      <p:sp>
+        <p:nvSpPr>
+          <p:cNvPr id="3" name="Notes Placeholder 2"/>
+          <p:cNvSpPr>
+            <a:spLocks noGrp="1"/>
+          </p:cNvSpPr>
+          <p:nvPr>
+            <p:ph type="body" idx="1"/>
+          </p:nvPr>
+        </p:nvSpPr>
+        <p:spPr/>
+        <p:txBody>
+          <a:bodyPr/>
+          <a:lstStyle/>
+          <a:p>
+            <a:r>
+              <a:rPr lang="en-US" dirty="0"/>
+              <a:t>Four experiment tracks: load testing, Cosmos DB checkpointer, Agent 365 onboarding, continuous evaluation
+Quality gate passed: 8 captures, zero policy failures, 21/21 judge checks, verified safety refusal and tool receipts
+Scale, Security, Operations gates: Conditional — partial evidence, named follow-ups
+Platform status, Data, Cost gates: Not testable in this PoC — require commercial/legal/platform confirmation
+Overall recommendation: conditional go for continued PoC-to-pilot investment, not an unconditional yes/no
+Sources: repository code and wiki Release-Evidence / Operations. Verified release 34178081808; historical experiments retain their original limits.</a:t>
+            </a:r>
+            <a:endParaRPr lang="en-US" dirty="0"/>
+          </a:p>
+        </p:txBody>
+      </p:sp>
+      <p:sp>
+        <p:nvSpPr>
+          <p:cNvPr id="4" name="Slide Number Placeholder 3"/>
+          <p:cNvSpPr>
+            <a:spLocks noGrp="1"/>
+          </p:cNvSpPr>
+          <p:nvPr>
+            <p:ph type="sldNum" sz="quarter" idx="10"/>
+          </p:nvPr>
+        </p:nvSpPr>
+        <p:spPr/>
+        <p:txBody>
+          <a:bodyPr/>
+          <a:lstStyle/>
+          <a:p>
+            <a:fld id="{F7021451-1387-4CA6-816F-3879F97B5CBC}" type="slidenum">
+              <a:rPr lang="en-US"/>
+              <a:t>13</a:t>
+            </a:fld>
+            <a:endParaRPr lang="en-US"/>
+          </a:p>
+        </p:txBody>
+      </p:sp>
+    </p:spTree>
+    <p:extLst>
+      <p:ext uri="{BB962C8B-B14F-4D97-AF65-F5344CB8AC3E}">
+        <p14:creationId xmlns:p14="http://schemas.microsoft.com/office/powerpoint/2010/main" val="1024086991"/>
+      </p:ext>
+    </p:extLst>
+  </p:cSld>
+  <p:clrMapOvr>
+    <a:masterClrMapping/>
+  </p:clrMapOvr>
+</p:notes>
+</file>
+
+<file path=ppt/notesSlides/notesSlide14.xml><?xml version="1.0" encoding="utf-8"?>
+<p:notes xmlns:a="http://schemas.openxmlformats.org/drawingml/2006/main" xmlns:r="http://schemas.openxmlformats.org/officeDocument/2006/relationships" xmlns:p="http://schemas.openxmlformats.org/presentationml/2006/main">
+  <p:cSld>
+    <p:spTree>
+      <p:nvGrpSpPr>
+        <p:cNvPr id="1" name=""/>
+        <p:cNvGrpSpPr/>
+        <p:nvPr/>
+      </p:nvGrpSpPr>
+      <p:grpSpPr>
+        <a:xfrm>
+          <a:off x="0" y="0"/>
+          <a:ext cx="0" cy="0"/>
+          <a:chOff x="0" y="0"/>
+          <a:chExt cx="0" cy="0"/>
+        </a:xfrm>
+      </p:grpSpPr>
+      <p:sp>
+        <p:nvSpPr>
+          <p:cNvPr id="2" name="Slide Image Placeholder 1"/>
+          <p:cNvSpPr>
+            <a:spLocks noGrp="1" noRot="1" noChangeAspect="1"/>
+          </p:cNvSpPr>
+          <p:nvPr>
+            <p:ph type="sldImg"/>
+          </p:nvPr>
+        </p:nvSpPr>
+        <p:spPr/>
+      </p:sp>
+      <p:sp>
+        <p:nvSpPr>
+          <p:cNvPr id="3" name="Notes Placeholder 2"/>
+          <p:cNvSpPr>
+            <a:spLocks noGrp="1"/>
+          </p:cNvSpPr>
+          <p:nvPr>
+            <p:ph type="body" idx="1"/>
+          </p:nvPr>
+        </p:nvSpPr>
+        <p:spPr/>
+        <p:txBody>
+          <a:bodyPr/>
+          <a:lstStyle/>
+          <a:p>
+            <a:r>
+              <a:rPr lang="en-US" dirty="0"/>
+              <a:t>The deployment and evaluation ran for real; the MCP security telemetry is synthetic, not live customer data
+Repository: github.com/devopsabcs-engineering/foundry-hosted-agents
+Wiki: current architecture, verified release artifacts, operational runbook, and resolved WI-11 history
+Full bilingual step-by-step labs: this deck’s companion GitHub Pages site
+Production v34 smoke passed; zero trailing-window exceptions is not a soak test or proof of complete distributed tracing
+Sources: repository code and wiki Release-Evidence / Operations. Verified release 34178081808; historical experiments retain their original limits.</a:t>
+            </a:r>
+            <a:endParaRPr lang="en-US" dirty="0"/>
+          </a:p>
+        </p:txBody>
+      </p:sp>
+      <p:sp>
+        <p:nvSpPr>
+          <p:cNvPr id="4" name="Slide Number Placeholder 3"/>
+          <p:cNvSpPr>
+            <a:spLocks noGrp="1"/>
+          </p:cNvSpPr>
+          <p:nvPr>
+            <p:ph type="sldNum" sz="quarter" idx="10"/>
+          </p:nvPr>
+        </p:nvSpPr>
+        <p:spPr/>
+        <p:txBody>
+          <a:bodyPr/>
+          <a:lstStyle/>
+          <a:p>
+            <a:fld id="{F7021451-1387-4CA6-816F-3879F97B5CBC}" type="slidenum">
+              <a:rPr lang="en-US"/>
+              <a:t>14</a:t>
             </a:fld>
             <a:endParaRPr lang="en-US"/>
           </a:p>
@@ -687,7 +1069,9 @@
           <a:p>
             <a:r>
               <a:rPr lang="en-US" dirty="0"/>
-              <a:t/>
+              <a:t>Seven release jobs succeeded; recovery skipped. Staging 6; production 33 to 34. Both production gates used normal reviewer approval. PoC environment, not enterprise production certification.
+Source: https://github.com/devopsabcs-engineering/foundry-hosted-agents/actions/runs/34178081808
+Evidence: assets/release-evidence/source; SHA-256 manifest: assets/release-evidence/manifest.json. Images render downloaded artifacts, not native portal UI.</a:t>
             </a:r>
             <a:endParaRPr lang="en-US" dirty="0"/>
           </a:p>
@@ -775,7 +1159,9 @@
           <a:p>
             <a:r>
               <a:rPr lang="en-US" dirty="0"/>
-              <a:t/>
+              <a:t>Eight captures; seven reports judged on coherence, groundedness, task adherence. All 21 passed at unchanged 100% thresholds. inject-001: deterministic safety refusal with no tools, not a judge pass. Zero policy failures. Incomplete output is retried, not rescored.
+Source: https://github.com/devopsabcs-engineering/foundry-hosted-agents/actions/runs/34178081808
+Evidence: assets/release-evidence/source; SHA-256 manifest: assets/release-evidence/manifest.json. Images render downloaded artifacts, not native portal UI.</a:t>
             </a:r>
             <a:endParaRPr lang="en-US" dirty="0"/>
           </a:p>
@@ -863,7 +1249,9 @@
           <a:p>
             <a:r>
               <a:rPr lang="en-US" dirty="0"/>
-              <a:t/>
+              <a:t>28 ToolMessage-derived receipts. tp-001 shows both Defender and both Anomaly tools. Receipts prove execution, not semantic correctness. Synthetic fixtures are not live Defender or airline telemetry. Safety case: no further tools. Bounded evidence attached to response.completed.
+Source: https://github.com/devopsabcs-engineering/foundry-hosted-agents/actions/runs/34178081808
+Evidence: assets/release-evidence/source; SHA-256 manifest: assets/release-evidence/manifest.json. Images render downloaded artifacts, not native portal UI.</a:t>
             </a:r>
             <a:endParaRPr lang="en-US" dirty="0"/>
           </a:p>
@@ -951,7 +1339,9 @@
           <a:p>
             <a:r>
               <a:rPr lang="en-US" dirty="0"/>
-              <a:t/>
+              <a:t>Version 34 active, toolbox 1. Exact-version smoke succeeded. At 02:12:02 UTC AppExceptions for the trailing ten minutes returned zero. Not a ten-minute soak or complete tracing proof. Quality suite ran on staging. Production rebuilds the same source with evaluated MCP digests. Manual recovery; no automatic rollback or canary.
+Source: https://github.com/devopsabcs-engineering/foundry-hosted-agents/actions/runs/34178081808
+Evidence: assets/release-evidence/source; SHA-256 manifest: assets/release-evidence/manifest.json. Images render downloaded artifacts, not native portal UI.</a:t>
             </a:r>
             <a:endParaRPr lang="en-US" dirty="0"/>
           </a:p>
@@ -1039,7 +1429,16 @@
           <a:p>
             <a:r>
               <a:rPr lang="en-US" dirty="0"/>
-              <a:t/>
+              <a:t>Lab 00 — Prerequisites and environment setup
+Lab 01 — Architecture deep dive (LangGraph supervisor/specialists)
+Lab 02 — Deploy the MCP tool servers
+Lab 03 — Provision and deploy the hosted agent (azd)
+Lab 04 — Invoke the agent and read traces
+Lab 05 — Evaluations: deterministic + LLM-as-judge
+Lab 06 — CI/CD: evaluation-gated release pipeline
+Lab 07 — Real-world troubleshooting: RBAC 401
+Lab 08 — Production readiness and decision gates
+Sources: repository code and wiki Release-Evidence / Operations. Verified release 34178081808; historical experiments retain their original limits.</a:t>
             </a:r>
             <a:endParaRPr lang="en-US" dirty="0"/>
           </a:p>
@@ -1127,7 +1526,12 @@
           <a:p>
             <a:r>
               <a:rPr lang="en-US" dirty="0"/>
-              <a:t/>
+              <a:t>A LangGraph supervisor routes to three specialist nodes: Evidence Investigator, Risk Analyst, Report Composer
+Each specialist has its own prompt, tool permissions, and evaluation criteria
+Tool isolation by role: Evidence Investigator → defender-conn only, Risk Analyst → anomaly-conn only
+The Report Composer has zero tool access — it only synthesizes
+Supported versioned MCP transport, fresh Entra tokens and RemoteTool connections now work; runtime receipts prove specialist tool execution
+Sources: repository code and wiki Release-Evidence / Operations. Verified release 34178081808; historical experiments retain their original limits.</a:t>
             </a:r>
             <a:endParaRPr lang="en-US" dirty="0"/>
           </a:p>
@@ -1215,7 +1619,12 @@
           <a:p>
             <a:r>
               <a:rPr lang="en-US" dirty="0"/>
-              <a:t/>
+              <a:t>Layer 1 — Implementation: custom MCP server code (Defender tools, anomaly tools)
+Layer 2 — Hosting: independent Azure Container Apps, own auth/networking/health checks
+Layer 3 — Registration: Foundry connections define endpoint + credential policy per MCP server
+Layer 4 — Consumption: Foundry Toolbox aggregates registered tools for reuse across agents
+The Toolbox is the registration/aggregation layer — not the hosting runtime for your MCP code
+Sources: repository code and wiki Release-Evidence / Operations. Verified release 34178081808; historical experiments retain their original limits.</a:t>
             </a:r>
             <a:endParaRPr lang="en-US" dirty="0"/>
           </a:p>
@@ -1303,7 +1712,12 @@
           <a:p>
             <a:r>
               <a:rPr lang="en-US" dirty="0"/>
-              <a:t/>
+              <a:t>azure.yaml wires the Foundry project, model deployment, Toolbox connections, and the hosted agent service
+kind: hosted — Foundry operates the session compute; you own only the graph code
+dependencyResolution: remote_build — Foundry builds your Python dependencies server-side
+protocol: responses — OpenAI-compatible Responses protocol with streaming support
+azd provision creates infrastructure; azd deploy publishes a new agent version — separate lifecycles
+Sources: repository code and wiki Release-Evidence / Operations. Verified release 34178081808; historical experiments retain their original limits.</a:t>
             </a:r>
             <a:endParaRPr lang="en-US" dirty="0"/>
           </a:p>
@@ -1813,6 +2227,42 @@
           </a:p>
         </p:txBody>
       </p:sp>
+      <p:sp>
+        <p:nvSpPr>
+          <p:cNvPr id="7" name="Text 4"/>
+          <p:cNvSpPr/>
+          <p:nvPr/>
+        </p:nvSpPr>
+        <p:spPr>
+          <a:xfrm>
+            <a:off x="11338560" y="6528816"/>
+            <a:ext cx="548640" cy="219456"/>
+          </a:xfrm>
+          <a:prstGeom prst="rect">
+            <a:avLst/>
+          </a:prstGeom>
+          <a:noFill/>
+          <a:ln/>
+        </p:spPr>
+        <p:txBody>
+          <a:bodyPr wrap="square" rtlCol="0" anchor="ctr"/>
+          <a:lstStyle/>
+          <a:p>
+            <a:pPr algn="r" indent="0" marL="0">
+              <a:buNone/>
+            </a:pPr>
+            <a:r>
+              <a:rPr lang="en-US" sz="900" dirty="0">
+                <a:solidFill>
+                  <a:srgbClr val="767676"/>
+                </a:solidFill>
+              </a:rPr>
+              <a:t>1 / 14</a:t>
+            </a:r>
+            <a:endParaRPr lang="en-US" sz="900" dirty="0"/>
+          </a:p>
+        </p:txBody>
+      </p:sp>
     </p:spTree>
   </p:cSld>
   <p:clrMapOvr>
@@ -1898,7 +2348,7 @@
                 <a:ea typeface="Segoe UI" pitchFamily="34" charset="-122"/>
                 <a:cs typeface="Segoe UI" pitchFamily="34" charset="-120"/>
               </a:rPr>
-              <a:t>WRAP-UP</a:t>
+              <a:t>EVALUATION</a:t>
             </a:r>
             <a:endParaRPr lang="en-US" sz="1100" dirty="0"/>
           </a:p>
@@ -1937,7 +2387,7 @@
                 <a:ea typeface="Segoe UI" pitchFamily="34" charset="-122"/>
                 <a:cs typeface="Segoe UI" pitchFamily="34" charset="-120"/>
               </a:rPr>
-              <a:t>Everything Here Is Real</a:t>
+              <a:t>Deterministic Checks + LLM-as-Judge Rubrics</a:t>
             </a:r>
             <a:endParaRPr lang="en-US" sz="2600" dirty="0"/>
           </a:p>
@@ -2000,8 +2450,7 @@
                 <a:ea typeface="Segoe UI" pitchFamily="34" charset="-122"/>
                 <a:cs typeface="Segoe UI" pitchFamily="34" charset="-120"/>
               </a:rPr>
-              <a:t>Every command, screenshot, and log excerpt in this workshop comes from a real deployment, not a simulation
-</a:t>
+              <a:t>Golden dataset: 8 categories (true/false positive, ambiguous, missing data, conflicting tools, prompt injection, unauthorized actions, unsupported conclusions)</a:t>
             </a:r>
             <a:endParaRPr lang="en-US" sz="1500" dirty="0"/>
           </a:p>
@@ -2022,8 +2471,7 @@
                 <a:ea typeface="Segoe UI" pitchFamily="34" charset="-122"/>
                 <a:cs typeface="Segoe UI" pitchFamily="34" charset="-120"/>
               </a:rPr>
-              <a:t>Repository: github.com/devopsabcs-engineering/foundry-hosted-agents
-</a:t>
+              <a:t>Deterministic: schema validity, required citations, allowed tool calls, policy constraints — fast, reproducible</a:t>
             </a:r>
             <a:endParaRPr lang="en-US" sz="1500" dirty="0"/>
           </a:p>
@@ -2044,8 +2492,7 @@
                 <a:ea typeface="Segoe UI" pitchFamily="34" charset="-122"/>
                 <a:cs typeface="Segoe UI" pitchFamily="34" charset="-120"/>
               </a:rPr>
-              <a:t>Wiki: architecture notes, manual-agent workaround, and the live RBAC 401 investigation log
-</a:t>
+              <a:t>Verified Foundry judges: coherence, groundedness, task adherence. Seven reports per metric, 21/21 passed at unchanged 100% thresholds</a:t>
             </a:r>
             <a:endParaRPr lang="en-US" sz="1500" dirty="0"/>
           </a:p>
@@ -2066,8 +2513,7 @@
                 <a:ea typeface="Segoe UI" pitchFamily="34" charset="-122"/>
                 <a:cs typeface="Segoe UI" pitchFamily="34" charset="-120"/>
               </a:rPr>
-              <a:t>Full bilingual step-by-step labs: this deck’s companion GitHub Pages site
-</a:t>
+              <a:t>Eight captures, zero deterministic policy failures; inject-001 is a verified safety refusal with no tool calls, not a model-judge result</a:t>
             </a:r>
             <a:endParaRPr lang="en-US" sz="1500" dirty="0"/>
           </a:p>
@@ -2088,8 +2534,7 @@
                 <a:ea typeface="Segoe UI" pitchFamily="34" charset="-122"/>
                 <a:cs typeface="Segoe UI" pitchFamily="34" charset="-120"/>
               </a:rPr>
-              <a:t>Fork it, run it, and follow WI-11 as it resolves
-</a:t>
+              <a:t>Policy rules (e.g. never claim an unauthorized remediation action) stay deterministic, not LLM-judged</a:t>
             </a:r>
             <a:endParaRPr lang="en-US" sz="1500" dirty="0"/>
           </a:p>
@@ -2097,7 +2542,7 @@
       </p:sp>
       <p:sp>
         <p:nvSpPr>
-          <p:cNvPr id="7" name="Shape 5"/>
+          <p:cNvPr id="8" name="Shape 5"/>
           <p:cNvSpPr/>
           <p:nvPr/>
         </p:nvSpPr>
@@ -2117,7 +2562,7 @@
       </p:sp>
       <p:sp>
         <p:nvSpPr>
-          <p:cNvPr id="8" name="Text 6"/>
+          <p:cNvPr id="9" name="Text 6"/>
           <p:cNvSpPr/>
           <p:nvPr/>
         </p:nvSpPr>
@@ -2148,7 +2593,43 @@
                 <a:ea typeface="Segoe UI" pitchFamily="34" charset="-122"/>
                 <a:cs typeface="Segoe UI" pitchFamily="34" charset="-120"/>
               </a:rPr>
-              <a:t>Foundry Hosted Agents Workshop — 9 / 9</a:t>
+              <a:t>Foundry Hosted Agents Workshop</a:t>
+            </a:r>
+            <a:endParaRPr lang="en-US" sz="900" dirty="0"/>
+          </a:p>
+        </p:txBody>
+      </p:sp>
+      <p:sp>
+        <p:nvSpPr>
+          <p:cNvPr id="10" name="Text 7"/>
+          <p:cNvSpPr/>
+          <p:nvPr/>
+        </p:nvSpPr>
+        <p:spPr>
+          <a:xfrm>
+            <a:off x="11338560" y="6528816"/>
+            <a:ext cx="548640" cy="219456"/>
+          </a:xfrm>
+          <a:prstGeom prst="rect">
+            <a:avLst/>
+          </a:prstGeom>
+          <a:noFill/>
+          <a:ln/>
+        </p:spPr>
+        <p:txBody>
+          <a:bodyPr wrap="square" rtlCol="0" anchor="ctr"/>
+          <a:lstStyle/>
+          <a:p>
+            <a:pPr algn="r" indent="0" marL="0">
+              <a:buNone/>
+            </a:pPr>
+            <a:r>
+              <a:rPr lang="en-US" sz="900" dirty="0">
+                <a:solidFill>
+                  <a:srgbClr val="767676"/>
+                </a:solidFill>
+              </a:rPr>
+              <a:t>10 / 14</a:t>
             </a:r>
             <a:endParaRPr lang="en-US" sz="900" dirty="0"/>
           </a:p>
@@ -2162,9 +2643,9 @@
 </p:sld>
 </file>
 
-<file path=ppt/slides/slide2.xml><?xml version="1.0" encoding="utf-8"?>
+<file path=ppt/slides/slide11.xml><?xml version="1.0" encoding="utf-8"?>
 <p:sld xmlns:a="http://schemas.openxmlformats.org/drawingml/2006/main" xmlns:r="http://schemas.openxmlformats.org/officeDocument/2006/relationships" xmlns:p="http://schemas.openxmlformats.org/presentationml/2006/main">
-  <p:cSld name="Slide 2">
+  <p:cSld name="Slide 11">
     <p:bg>
       <p:bgPr>
         <a:solidFill>
@@ -2239,7 +2720,7 @@
                 <a:ea typeface="Segoe UI" pitchFamily="34" charset="-122"/>
                 <a:cs typeface="Segoe UI" pitchFamily="34" charset="-120"/>
               </a:rPr>
-              <a:t>AGENDA</a:t>
+              <a:t>CI/CD</a:t>
             </a:r>
             <a:endParaRPr lang="en-US" sz="1100" dirty="0"/>
           </a:p>
@@ -2278,7 +2759,7 @@
                 <a:ea typeface="Segoe UI" pitchFamily="34" charset="-122"/>
                 <a:cs typeface="Segoe UI" pitchFamily="34" charset="-120"/>
               </a:rPr>
-              <a:t>Nine Labs, One Real Deployment</a:t>
+              <a:t>Evaluation-Gated Release Pipeline</a:t>
             </a:r>
             <a:endParaRPr lang="en-US" sz="2600" dirty="0"/>
           </a:p>
@@ -2341,8 +2822,7 @@
                 <a:ea typeface="Segoe UI" pitchFamily="34" charset="-122"/>
                 <a:cs typeface="Segoe UI" pitchFamily="34" charset="-120"/>
               </a:rPr>
-              <a:t>Lab 00 — Prerequisites and environment setup
-</a:t>
+              <a:t>Two manual pipelines: direct PoC deployment, or deploy-and-evaluate.yml with isolated staging and production accounts/projects</a:t>
             </a:r>
             <a:endParaRPr lang="en-US" sz="1500" dirty="0"/>
           </a:p>
@@ -2363,8 +2843,7 @@
                 <a:ea typeface="Segoe UI" pitchFamily="34" charset="-122"/>
                 <a:cs typeface="Segoe UI" pitchFamily="34" charset="-120"/>
               </a:rPr>
-              <a:t>Lab 01 — Architecture deep dive (LangGraph supervisor/specialists)
-</a:t>
+              <a:t>Full flow: lint/tests → Bicep validate → deploy immutable candidate to staging → smoke/contract/streaming tests</a:t>
             </a:r>
             <a:endParaRPr lang="en-US" sz="1500" dirty="0"/>
           </a:p>
@@ -2385,8 +2864,7 @@
                 <a:ea typeface="Segoe UI" pitchFamily="34" charset="-122"/>
                 <a:cs typeface="Segoe UI" pitchFamily="34" charset="-120"/>
               </a:rPr>
-              <a:t>Lab 02 — Deploy the MCP tool servers
-</a:t>
+              <a:t>Offline evaluation quality gate runs against the staging candidate before any manual production approval</a:t>
             </a:r>
             <a:endParaRPr lang="en-US" sz="1500" dirty="0"/>
           </a:p>
@@ -2407,8 +2885,7 @@
                 <a:ea typeface="Segoe UI" pitchFamily="34" charset="-122"/>
                 <a:cs typeface="Segoe UI" pitchFamily="34" charset="-120"/>
               </a:rPr>
-              <a:t>Lab 03 — Provision and deploy the hosted agent (azd)
-</a:t>
+              <a:t>Secretless OIDC federation — no stored client secrets in either pipeline</a:t>
             </a:r>
             <a:endParaRPr lang="en-US" sz="1500" dirty="0"/>
           </a:p>
@@ -2429,104 +2906,15 @@
                 <a:ea typeface="Segoe UI" pitchFamily="34" charset="-122"/>
                 <a:cs typeface="Segoe UI" pitchFamily="34" charset="-120"/>
               </a:rPr>
-              <a:t>Lab 04 — Invoke the agent and read traces
-</a:t>
+              <a:t>Run 34178081808 passed end to end: staging 6, production 34, exact evaluated MCP digests, normal approvals. Manual recovery; no automatic rollback or canary</a:t>
             </a:r>
             <a:endParaRPr lang="en-US" sz="1500" dirty="0"/>
           </a:p>
-          <a:p>
-            <a:pPr marL="254000" indent="-254000">
-              <a:lnSpc>
-                <a:spcPct val="125000"/>
-              </a:lnSpc>
-              <a:buSzPct val="100000"/>
-              <a:buChar char="●"/>
-            </a:pPr>
-            <a:r>
-              <a:rPr lang="en-US" sz="1500" dirty="0">
-                <a:solidFill>
-                  <a:srgbClr val="1A1A1A"/>
-                </a:solidFill>
-                <a:latin typeface="Segoe UI" pitchFamily="34" charset="0"/>
-                <a:ea typeface="Segoe UI" pitchFamily="34" charset="-122"/>
-                <a:cs typeface="Segoe UI" pitchFamily="34" charset="-120"/>
-              </a:rPr>
-              <a:t>Lab 05 — Evaluations: deterministic + LLM-as-judge
-</a:t>
-            </a:r>
-            <a:endParaRPr lang="en-US" sz="1500" dirty="0"/>
-          </a:p>
-          <a:p>
-            <a:pPr marL="254000" indent="-254000">
-              <a:lnSpc>
-                <a:spcPct val="125000"/>
-              </a:lnSpc>
-              <a:buSzPct val="100000"/>
-              <a:buChar char="●"/>
-            </a:pPr>
-            <a:r>
-              <a:rPr lang="en-US" sz="1500" dirty="0">
-                <a:solidFill>
-                  <a:srgbClr val="1A1A1A"/>
-                </a:solidFill>
-                <a:latin typeface="Segoe UI" pitchFamily="34" charset="0"/>
-                <a:ea typeface="Segoe UI" pitchFamily="34" charset="-122"/>
-                <a:cs typeface="Segoe UI" pitchFamily="34" charset="-120"/>
-              </a:rPr>
-              <a:t>Lab 06 — CI/CD: evaluation-gated release pipeline
-</a:t>
-            </a:r>
-            <a:endParaRPr lang="en-US" sz="1500" dirty="0"/>
-          </a:p>
-          <a:p>
-            <a:pPr marL="254000" indent="-254000">
-              <a:lnSpc>
-                <a:spcPct val="125000"/>
-              </a:lnSpc>
-              <a:buSzPct val="100000"/>
-              <a:buChar char="●"/>
-            </a:pPr>
-            <a:r>
-              <a:rPr lang="en-US" sz="1500" dirty="0">
-                <a:solidFill>
-                  <a:srgbClr val="1A1A1A"/>
-                </a:solidFill>
-                <a:latin typeface="Segoe UI" pitchFamily="34" charset="0"/>
-                <a:ea typeface="Segoe UI" pitchFamily="34" charset="-122"/>
-                <a:cs typeface="Segoe UI" pitchFamily="34" charset="-120"/>
-              </a:rPr>
-              <a:t>Lab 07 — Real-world troubleshooting: RBAC 401
-</a:t>
-            </a:r>
-            <a:endParaRPr lang="en-US" sz="1500" dirty="0"/>
-          </a:p>
-          <a:p>
-            <a:pPr marL="254000" indent="-254000">
-              <a:lnSpc>
-                <a:spcPct val="125000"/>
-              </a:lnSpc>
-              <a:buSzPct val="100000"/>
-              <a:buChar char="●"/>
-            </a:pPr>
-            <a:r>
-              <a:rPr lang="en-US" sz="1500" dirty="0">
-                <a:solidFill>
-                  <a:srgbClr val="1A1A1A"/>
-                </a:solidFill>
-                <a:latin typeface="Segoe UI" pitchFamily="34" charset="0"/>
-                <a:ea typeface="Segoe UI" pitchFamily="34" charset="-122"/>
-                <a:cs typeface="Segoe UI" pitchFamily="34" charset="-120"/>
-              </a:rPr>
-              <a:t>Lab 08 — Production readiness and decision gates
-</a:t>
-            </a:r>
-            <a:endParaRPr lang="en-US" sz="1500" dirty="0"/>
-          </a:p>
-        </p:txBody>
-      </p:sp>
-      <p:sp>
-        <p:nvSpPr>
-          <p:cNvPr id="7" name="Shape 5"/>
+        </p:txBody>
+      </p:sp>
+      <p:sp>
+        <p:nvSpPr>
+          <p:cNvPr id="8" name="Shape 5"/>
           <p:cNvSpPr/>
           <p:nvPr/>
         </p:nvSpPr>
@@ -2546,7 +2934,7 @@
       </p:sp>
       <p:sp>
         <p:nvSpPr>
-          <p:cNvPr id="8" name="Text 6"/>
+          <p:cNvPr id="9" name="Text 6"/>
           <p:cNvSpPr/>
           <p:nvPr/>
         </p:nvSpPr>
@@ -2577,7 +2965,43 @@
                 <a:ea typeface="Segoe UI" pitchFamily="34" charset="-122"/>
                 <a:cs typeface="Segoe UI" pitchFamily="34" charset="-120"/>
               </a:rPr>
-              <a:t>Foundry Hosted Agents Workshop — 1 / 9</a:t>
+              <a:t>Foundry Hosted Agents Workshop</a:t>
+            </a:r>
+            <a:endParaRPr lang="en-US" sz="900" dirty="0"/>
+          </a:p>
+        </p:txBody>
+      </p:sp>
+      <p:sp>
+        <p:nvSpPr>
+          <p:cNvPr id="10" name="Text 7"/>
+          <p:cNvSpPr/>
+          <p:nvPr/>
+        </p:nvSpPr>
+        <p:spPr>
+          <a:xfrm>
+            <a:off x="11338560" y="6528816"/>
+            <a:ext cx="548640" cy="219456"/>
+          </a:xfrm>
+          <a:prstGeom prst="rect">
+            <a:avLst/>
+          </a:prstGeom>
+          <a:noFill/>
+          <a:ln/>
+        </p:spPr>
+        <p:txBody>
+          <a:bodyPr wrap="square" rtlCol="0" anchor="ctr"/>
+          <a:lstStyle/>
+          <a:p>
+            <a:pPr algn="r" indent="0" marL="0">
+              <a:buNone/>
+            </a:pPr>
+            <a:r>
+              <a:rPr lang="en-US" sz="900" dirty="0">
+                <a:solidFill>
+                  <a:srgbClr val="767676"/>
+                </a:solidFill>
+              </a:rPr>
+              <a:t>11 / 14</a:t>
             </a:r>
             <a:endParaRPr lang="en-US" sz="900" dirty="0"/>
           </a:p>
@@ -2591,9 +3015,9 @@
 </p:sld>
 </file>
 
-<file path=ppt/slides/slide3.xml><?xml version="1.0" encoding="utf-8"?>
+<file path=ppt/slides/slide12.xml><?xml version="1.0" encoding="utf-8"?>
 <p:sld xmlns:a="http://schemas.openxmlformats.org/drawingml/2006/main" xmlns:r="http://schemas.openxmlformats.org/officeDocument/2006/relationships" xmlns:p="http://schemas.openxmlformats.org/presentationml/2006/main">
-  <p:cSld name="Slide 3">
+  <p:cSld name="Slide 12">
     <p:bg>
       <p:bgPr>
         <a:solidFill>
@@ -2630,7 +3054,7 @@
             <a:avLst/>
           </a:prstGeom>
           <a:solidFill>
-            <a:srgbClr val="0078D4"/>
+            <a:srgbClr val="107C10"/>
           </a:solidFill>
           <a:ln/>
         </p:spPr>
@@ -2662,13 +3086,13 @@
             <a:r>
               <a:rPr lang="en-US" sz="1100" b="1" spc="100" kern="0" dirty="0">
                 <a:solidFill>
-                  <a:srgbClr val="0078D4"/>
-                </a:solidFill>
-                <a:latin typeface="Segoe UI" pitchFamily="34" charset="0"/>
-                <a:ea typeface="Segoe UI" pitchFamily="34" charset="-122"/>
-                <a:cs typeface="Segoe UI" pitchFamily="34" charset="-120"/>
-              </a:rPr>
-              <a:t>ARCHITECTURE</a:t>
+                  <a:srgbClr val="107C10"/>
+                </a:solidFill>
+                <a:latin typeface="Segoe UI" pitchFamily="34" charset="0"/>
+                <a:ea typeface="Segoe UI" pitchFamily="34" charset="-122"/>
+                <a:cs typeface="Segoe UI" pitchFamily="34" charset="-120"/>
+              </a:rPr>
+              <a:t>REAL-WORLD TROUBLESHOOTING</a:t>
             </a:r>
             <a:endParaRPr lang="en-US" sz="1100" dirty="0"/>
           </a:p>
@@ -2707,7 +3131,7 @@
                 <a:ea typeface="Segoe UI" pitchFamily="34" charset="-122"/>
                 <a:cs typeface="Segoe UI" pitchFamily="34" charset="-120"/>
               </a:rPr>
-              <a:t>Supervisor + Specialist Graph</a:t>
+              <a:t>WI-11 Resolved: Separate Observation from RCA</a:t>
             </a:r>
             <a:endParaRPr lang="en-US" sz="2600" dirty="0"/>
           </a:p>
@@ -2770,8 +3194,7 @@
                 <a:ea typeface="Segoe UI" pitchFamily="34" charset="-122"/>
                 <a:cs typeface="Segoe UI" pitchFamily="34" charset="-120"/>
               </a:rPr>
-              <a:t>A LangGraph supervisor routes to three specialist nodes: Evidence Investigator, Risk Analyst, Report Composer
-</a:t>
+              <a:t>Historical model 401 recovered on v32; the same runtime principal now passes the complete v34 production release</a:t>
             </a:r>
             <a:endParaRPr lang="en-US" sz="1500" dirty="0"/>
           </a:p>
@@ -2792,8 +3215,7 @@
                 <a:ea typeface="Segoe UI" pitchFamily="34" charset="-122"/>
                 <a:cs typeface="Segoe UI" pitchFamily="34" charset="-120"/>
               </a:rPr>
-              <a:t>Each specialist has its own prompt, tool permissions, and evaluation criteria
-</a:t>
+              <a:t>Validate the actual runtime principal, role dataActions, scope, conditions, network policy and token audience</a:t>
             </a:r>
             <a:endParaRPr lang="en-US" sz="1500" dirty="0"/>
           </a:p>
@@ -2814,8 +3236,7 @@
                 <a:ea typeface="Segoe UI" pitchFamily="34" charset="-122"/>
                 <a:cs typeface="Segoe UI" pitchFamily="34" charset="-120"/>
               </a:rPr>
-              <a:t>Tool isolation by role: Evidence Investigator → defender-conn only, Risk Analyst → anomaly-conn only
-</a:t>
+              <a:t>Separate MCP failures were fixed with the supported versioned endpoint, RemoteTool connections and current protocol negotiation</a:t>
             </a:r>
             <a:endParaRPr lang="en-US" sz="1500" dirty="0"/>
           </a:p>
@@ -2836,8 +3257,7 @@
                 <a:ea typeface="Segoe UI" pitchFamily="34" charset="-122"/>
                 <a:cs typeface="Segoe UI" pitchFamily="34" charset="-120"/>
               </a:rPr>
-              <a:t>The Report Composer has zero tool access — it only synthesizes
-</a:t>
+              <a:t>Original incident propagation and independent specialist lookups restored required evidence; strict evaluation thresholds were unchanged</a:t>
             </a:r>
             <a:endParaRPr lang="en-US" sz="1500" dirty="0"/>
           </a:p>
@@ -2858,16 +3278,36 @@
                 <a:ea typeface="Segoe UI" pitchFamily="34" charset="-122"/>
                 <a:cs typeface="Segoe UI" pitchFamily="34" charset="-120"/>
               </a:rPr>
-              <a:t>A known platform-side tool-resolution gap degrades gracefully to an honestly-labeled plain-LLM analysis instead of crashing
-</a:t>
+              <a:t>The old Azure cache explanation remains an unconfirmed hypothesis. A successful redeployment is recovery evidence, not a controlled server-side RCA</a:t>
             </a:r>
             <a:endParaRPr lang="en-US" sz="1500" dirty="0"/>
           </a:p>
-        </p:txBody>
-      </p:sp>
-      <p:sp>
-        <p:nvSpPr>
-          <p:cNvPr id="7" name="Shape 5"/>
+          <a:p>
+            <a:pPr marL="254000" indent="-254000">
+              <a:lnSpc>
+                <a:spcPct val="125000"/>
+              </a:lnSpc>
+              <a:buSzPct val="100000"/>
+              <a:buChar char="●"/>
+            </a:pPr>
+            <a:r>
+              <a:rPr lang="en-US" sz="1500" dirty="0">
+                <a:solidFill>
+                  <a:srgbClr val="1A1A1A"/>
+                </a:solidFill>
+                <a:latin typeface="Segoe UI" pitchFamily="34" charset="0"/>
+                <a:ea typeface="Segoe UI" pitchFamily="34" charset="-122"/>
+                <a:cs typeface="Segoe UI" pitchFamily="34" charset="-120"/>
+              </a:rPr>
+              <a:t>Support request 2609040400007027 is a historical reference; no support-ticket closure is claimed</a:t>
+            </a:r>
+            <a:endParaRPr lang="en-US" sz="1500" dirty="0"/>
+          </a:p>
+        </p:txBody>
+      </p:sp>
+      <p:sp>
+        <p:nvSpPr>
+          <p:cNvPr id="8" name="Shape 5"/>
           <p:cNvSpPr/>
           <p:nvPr/>
         </p:nvSpPr>
@@ -2887,7 +3327,7 @@
       </p:sp>
       <p:sp>
         <p:nvSpPr>
-          <p:cNvPr id="8" name="Text 6"/>
+          <p:cNvPr id="9" name="Text 6"/>
           <p:cNvSpPr/>
           <p:nvPr/>
         </p:nvSpPr>
@@ -2918,7 +3358,43 @@
                 <a:ea typeface="Segoe UI" pitchFamily="34" charset="-122"/>
                 <a:cs typeface="Segoe UI" pitchFamily="34" charset="-120"/>
               </a:rPr>
-              <a:t>Foundry Hosted Agents Workshop — 2 / 9</a:t>
+              <a:t>Foundry Hosted Agents Workshop</a:t>
+            </a:r>
+            <a:endParaRPr lang="en-US" sz="900" dirty="0"/>
+          </a:p>
+        </p:txBody>
+      </p:sp>
+      <p:sp>
+        <p:nvSpPr>
+          <p:cNvPr id="10" name="Text 7"/>
+          <p:cNvSpPr/>
+          <p:nvPr/>
+        </p:nvSpPr>
+        <p:spPr>
+          <a:xfrm>
+            <a:off x="11338560" y="6528816"/>
+            <a:ext cx="548640" cy="219456"/>
+          </a:xfrm>
+          <a:prstGeom prst="rect">
+            <a:avLst/>
+          </a:prstGeom>
+          <a:noFill/>
+          <a:ln/>
+        </p:spPr>
+        <p:txBody>
+          <a:bodyPr wrap="square" rtlCol="0" anchor="ctr"/>
+          <a:lstStyle/>
+          <a:p>
+            <a:pPr algn="r" indent="0" marL="0">
+              <a:buNone/>
+            </a:pPr>
+            <a:r>
+              <a:rPr lang="en-US" sz="900" dirty="0">
+                <a:solidFill>
+                  <a:srgbClr val="767676"/>
+                </a:solidFill>
+              </a:rPr>
+              <a:t>12 / 14</a:t>
             </a:r>
             <a:endParaRPr lang="en-US" sz="900" dirty="0"/>
           </a:p>
@@ -2932,9 +3408,9 @@
 </p:sld>
 </file>
 
-<file path=ppt/slides/slide4.xml><?xml version="1.0" encoding="utf-8"?>
+<file path=ppt/slides/slide13.xml><?xml version="1.0" encoding="utf-8"?>
 <p:sld xmlns:a="http://schemas.openxmlformats.org/drawingml/2006/main" xmlns:r="http://schemas.openxmlformats.org/officeDocument/2006/relationships" xmlns:p="http://schemas.openxmlformats.org/presentationml/2006/main">
-  <p:cSld name="Slide 4">
+  <p:cSld name="Slide 13">
     <p:bg>
       <p:bgPr>
         <a:solidFill>
@@ -3009,7 +3485,7 @@
                 <a:ea typeface="Segoe UI" pitchFamily="34" charset="-122"/>
                 <a:cs typeface="Segoe UI" pitchFamily="34" charset="-120"/>
               </a:rPr>
-              <a:t>TOOLS</a:t>
+              <a:t>PRODUCTION READINESS</a:t>
             </a:r>
             <a:endParaRPr lang="en-US" sz="1100" dirty="0"/>
           </a:p>
@@ -3048,7 +3524,7 @@
                 <a:ea typeface="Segoe UI" pitchFamily="34" charset="-122"/>
                 <a:cs typeface="Segoe UI" pitchFamily="34" charset="-120"/>
               </a:rPr>
-              <a:t>Four Layers: Implement, Host, Register, Consume</a:t>
+              <a:t>Honest Gates, Not False Confidence</a:t>
             </a:r>
             <a:endParaRPr lang="en-US" sz="2600" dirty="0"/>
           </a:p>
@@ -3111,8 +3587,7 @@
                 <a:ea typeface="Segoe UI" pitchFamily="34" charset="-122"/>
                 <a:cs typeface="Segoe UI" pitchFamily="34" charset="-120"/>
               </a:rPr>
-              <a:t>Layer 1 — Implementation: custom MCP server code (Defender tools, anomaly tools)
-</a:t>
+              <a:t>Four experiment tracks: load testing, Cosmos DB checkpointer, Agent 365 onboarding, continuous evaluation</a:t>
             </a:r>
             <a:endParaRPr lang="en-US" sz="1500" dirty="0"/>
           </a:p>
@@ -3133,8 +3608,7 @@
                 <a:ea typeface="Segoe UI" pitchFamily="34" charset="-122"/>
                 <a:cs typeface="Segoe UI" pitchFamily="34" charset="-120"/>
               </a:rPr>
-              <a:t>Layer 2 — Hosting: independent Azure Container Apps, own auth/networking/health checks
-</a:t>
+              <a:t>Quality gate passed: 8 captures, zero policy failures, 21/21 judge checks, verified safety refusal and tool receipts</a:t>
             </a:r>
             <a:endParaRPr lang="en-US" sz="1500" dirty="0"/>
           </a:p>
@@ -3155,8 +3629,7 @@
                 <a:ea typeface="Segoe UI" pitchFamily="34" charset="-122"/>
                 <a:cs typeface="Segoe UI" pitchFamily="34" charset="-120"/>
               </a:rPr>
-              <a:t>Layer 3 — Registration: Foundry connections define endpoint + credential policy per MCP server
-</a:t>
+              <a:t>Scale, Security, Operations gates: Conditional — partial evidence, named follow-ups</a:t>
             </a:r>
             <a:endParaRPr lang="en-US" sz="1500" dirty="0"/>
           </a:p>
@@ -3177,8 +3650,7 @@
                 <a:ea typeface="Segoe UI" pitchFamily="34" charset="-122"/>
                 <a:cs typeface="Segoe UI" pitchFamily="34" charset="-120"/>
               </a:rPr>
-              <a:t>Layer 4 — Consumption: Foundry Toolbox aggregates registered tools for reuse across agents
-</a:t>
+              <a:t>Platform status, Data, Cost gates: Not testable in this PoC — require commercial/legal/platform confirmation</a:t>
             </a:r>
             <a:endParaRPr lang="en-US" sz="1500" dirty="0"/>
           </a:p>
@@ -3199,8 +3671,7 @@
                 <a:ea typeface="Segoe UI" pitchFamily="34" charset="-122"/>
                 <a:cs typeface="Segoe UI" pitchFamily="34" charset="-120"/>
               </a:rPr>
-              <a:t>The Toolbox is the registration/aggregation layer — not the hosting runtime for your MCP code
-</a:t>
+              <a:t>Overall recommendation: conditional go for continued PoC-to-pilot investment, not an unconditional yes/no</a:t>
             </a:r>
             <a:endParaRPr lang="en-US" sz="1500" dirty="0"/>
           </a:p>
@@ -3208,7 +3679,7 @@
       </p:sp>
       <p:sp>
         <p:nvSpPr>
-          <p:cNvPr id="7" name="Shape 5"/>
+          <p:cNvPr id="8" name="Shape 5"/>
           <p:cNvSpPr/>
           <p:nvPr/>
         </p:nvSpPr>
@@ -3228,7 +3699,7 @@
       </p:sp>
       <p:sp>
         <p:nvSpPr>
-          <p:cNvPr id="8" name="Text 6"/>
+          <p:cNvPr id="9" name="Text 6"/>
           <p:cNvSpPr/>
           <p:nvPr/>
         </p:nvSpPr>
@@ -3259,7 +3730,43 @@
                 <a:ea typeface="Segoe UI" pitchFamily="34" charset="-122"/>
                 <a:cs typeface="Segoe UI" pitchFamily="34" charset="-120"/>
               </a:rPr>
-              <a:t>Foundry Hosted Agents Workshop — 3 / 9</a:t>
+              <a:t>Foundry Hosted Agents Workshop</a:t>
+            </a:r>
+            <a:endParaRPr lang="en-US" sz="900" dirty="0"/>
+          </a:p>
+        </p:txBody>
+      </p:sp>
+      <p:sp>
+        <p:nvSpPr>
+          <p:cNvPr id="10" name="Text 7"/>
+          <p:cNvSpPr/>
+          <p:nvPr/>
+        </p:nvSpPr>
+        <p:spPr>
+          <a:xfrm>
+            <a:off x="11338560" y="6528816"/>
+            <a:ext cx="548640" cy="219456"/>
+          </a:xfrm>
+          <a:prstGeom prst="rect">
+            <a:avLst/>
+          </a:prstGeom>
+          <a:noFill/>
+          <a:ln/>
+        </p:spPr>
+        <p:txBody>
+          <a:bodyPr wrap="square" rtlCol="0" anchor="ctr"/>
+          <a:lstStyle/>
+          <a:p>
+            <a:pPr algn="r" indent="0" marL="0">
+              <a:buNone/>
+            </a:pPr>
+            <a:r>
+              <a:rPr lang="en-US" sz="900" dirty="0">
+                <a:solidFill>
+                  <a:srgbClr val="767676"/>
+                </a:solidFill>
+              </a:rPr>
+              <a:t>13 / 14</a:t>
             </a:r>
             <a:endParaRPr lang="en-US" sz="900" dirty="0"/>
           </a:p>
@@ -3273,9 +3780,9 @@
 </p:sld>
 </file>
 
-<file path=ppt/slides/slide5.xml><?xml version="1.0" encoding="utf-8"?>
+<file path=ppt/slides/slide14.xml><?xml version="1.0" encoding="utf-8"?>
 <p:sld xmlns:a="http://schemas.openxmlformats.org/drawingml/2006/main" xmlns:r="http://schemas.openxmlformats.org/officeDocument/2006/relationships" xmlns:p="http://schemas.openxmlformats.org/presentationml/2006/main">
-  <p:cSld name="Slide 5">
+  <p:cSld name="Slide 14">
     <p:bg>
       <p:bgPr>
         <a:solidFill>
@@ -3350,7 +3857,7 @@
                 <a:ea typeface="Segoe UI" pitchFamily="34" charset="-122"/>
                 <a:cs typeface="Segoe UI" pitchFamily="34" charset="-120"/>
               </a:rPr>
-              <a:t>DEPLOYMENT</a:t>
+              <a:t>WRAP-UP</a:t>
             </a:r>
             <a:endParaRPr lang="en-US" sz="1100" dirty="0"/>
           </a:p>
@@ -3389,7 +3896,7 @@
                 <a:ea typeface="Segoe UI" pitchFamily="34" charset="-122"/>
                 <a:cs typeface="Segoe UI" pitchFamily="34" charset="-120"/>
               </a:rPr>
-              <a:t>One Manifest: azure.yaml + azd</a:t>
+              <a:t>A Proven Release, with Explicit Limits</a:t>
             </a:r>
             <a:endParaRPr lang="en-US" sz="2600" dirty="0"/>
           </a:p>
@@ -3452,8 +3959,7 @@
                 <a:ea typeface="Segoe UI" pitchFamily="34" charset="-122"/>
                 <a:cs typeface="Segoe UI" pitchFamily="34" charset="-120"/>
               </a:rPr>
-              <a:t>azure.yaml wires the Foundry project, model deployment, Toolbox connections, and the hosted agent service
-</a:t>
+              <a:t>The deployment and evaluation ran for real; the MCP security telemetry is synthetic, not live customer data</a:t>
             </a:r>
             <a:endParaRPr lang="en-US" sz="1500" dirty="0"/>
           </a:p>
@@ -3474,8 +3980,7 @@
                 <a:ea typeface="Segoe UI" pitchFamily="34" charset="-122"/>
                 <a:cs typeface="Segoe UI" pitchFamily="34" charset="-120"/>
               </a:rPr>
-              <a:t>kind: hosted — Foundry operates the session compute; you own only the graph code
-</a:t>
+              <a:t>Repository: github.com/devopsabcs-engineering/foundry-hosted-agents</a:t>
             </a:r>
             <a:endParaRPr lang="en-US" sz="1500" dirty="0"/>
           </a:p>
@@ -3496,8 +4001,7 @@
                 <a:ea typeface="Segoe UI" pitchFamily="34" charset="-122"/>
                 <a:cs typeface="Segoe UI" pitchFamily="34" charset="-120"/>
               </a:rPr>
-              <a:t>dependencyResolution: remote_build — Foundry builds your Python dependencies server-side
-</a:t>
+              <a:t>Wiki: current architecture, verified release artifacts, operational runbook, and resolved WI-11 history</a:t>
             </a:r>
             <a:endParaRPr lang="en-US" sz="1500" dirty="0"/>
           </a:p>
@@ -3518,8 +4022,7 @@
                 <a:ea typeface="Segoe UI" pitchFamily="34" charset="-122"/>
                 <a:cs typeface="Segoe UI" pitchFamily="34" charset="-120"/>
               </a:rPr>
-              <a:t>protocol: responses — OpenAI-compatible Responses protocol with streaming support
-</a:t>
+              <a:t>Full bilingual step-by-step labs: this deck’s companion GitHub Pages site</a:t>
             </a:r>
             <a:endParaRPr lang="en-US" sz="1500" dirty="0"/>
           </a:p>
@@ -3540,8 +4043,7 @@
                 <a:ea typeface="Segoe UI" pitchFamily="34" charset="-122"/>
                 <a:cs typeface="Segoe UI" pitchFamily="34" charset="-120"/>
               </a:rPr>
-              <a:t>azd provision creates infrastructure; azd deploy publishes a new agent version — separate lifecycles
-</a:t>
+              <a:t>Production v34 smoke passed; zero trailing-window exceptions is not a soak test or proof of complete distributed tracing</a:t>
             </a:r>
             <a:endParaRPr lang="en-US" sz="1500" dirty="0"/>
           </a:p>
@@ -3549,7 +4051,7 @@
       </p:sp>
       <p:sp>
         <p:nvSpPr>
-          <p:cNvPr id="7" name="Shape 5"/>
+          <p:cNvPr id="8" name="Shape 5"/>
           <p:cNvSpPr/>
           <p:nvPr/>
         </p:nvSpPr>
@@ -3569,7 +4071,7 @@
       </p:sp>
       <p:sp>
         <p:nvSpPr>
-          <p:cNvPr id="8" name="Text 6"/>
+          <p:cNvPr id="9" name="Text 6"/>
           <p:cNvSpPr/>
           <p:nvPr/>
         </p:nvSpPr>
@@ -3600,7 +4102,915 @@
                 <a:ea typeface="Segoe UI" pitchFamily="34" charset="-122"/>
                 <a:cs typeface="Segoe UI" pitchFamily="34" charset="-120"/>
               </a:rPr>
-              <a:t>Foundry Hosted Agents Workshop — 4 / 9</a:t>
+              <a:t>Foundry Hosted Agents Workshop</a:t>
+            </a:r>
+            <a:endParaRPr lang="en-US" sz="900" dirty="0"/>
+          </a:p>
+        </p:txBody>
+      </p:sp>
+      <p:sp>
+        <p:nvSpPr>
+          <p:cNvPr id="10" name="Text 7"/>
+          <p:cNvSpPr/>
+          <p:nvPr/>
+        </p:nvSpPr>
+        <p:spPr>
+          <a:xfrm>
+            <a:off x="11338560" y="6528816"/>
+            <a:ext cx="548640" cy="219456"/>
+          </a:xfrm>
+          <a:prstGeom prst="rect">
+            <a:avLst/>
+          </a:prstGeom>
+          <a:noFill/>
+          <a:ln/>
+        </p:spPr>
+        <p:txBody>
+          <a:bodyPr wrap="square" rtlCol="0" anchor="ctr"/>
+          <a:lstStyle/>
+          <a:p>
+            <a:pPr algn="r" indent="0" marL="0">
+              <a:buNone/>
+            </a:pPr>
+            <a:r>
+              <a:rPr lang="en-US" sz="900" dirty="0">
+                <a:solidFill>
+                  <a:srgbClr val="767676"/>
+                </a:solidFill>
+              </a:rPr>
+              <a:t>14 / 14</a:t>
+            </a:r>
+            <a:endParaRPr lang="en-US" sz="900" dirty="0"/>
+          </a:p>
+        </p:txBody>
+      </p:sp>
+    </p:spTree>
+  </p:cSld>
+  <p:clrMapOvr>
+    <a:masterClrMapping/>
+  </p:clrMapOvr>
+</p:sld>
+</file>
+
+<file path=ppt/slides/slide2.xml><?xml version="1.0" encoding="utf-8"?>
+<p:sld xmlns:a="http://schemas.openxmlformats.org/drawingml/2006/main" xmlns:r="http://schemas.openxmlformats.org/officeDocument/2006/relationships" xmlns:p="http://schemas.openxmlformats.org/presentationml/2006/main">
+  <p:cSld name="Slide 2">
+    <p:bg>
+      <p:bgPr>
+        <a:solidFill>
+          <a:srgbClr val="FFFFFF"/>
+        </a:solidFill>
+      </p:bgPr>
+    </p:bg>
+    <p:spTree>
+      <p:nvGrpSpPr>
+        <p:cNvPr id="1" name=""/>
+        <p:cNvGrpSpPr/>
+        <p:nvPr/>
+      </p:nvGrpSpPr>
+      <p:grpSpPr>
+        <a:xfrm>
+          <a:off x="0" y="0"/>
+          <a:ext cx="0" cy="0"/>
+          <a:chOff x="0" y="0"/>
+          <a:chExt cx="0" cy="0"/>
+        </a:xfrm>
+      </p:grpSpPr>
+      <p:sp>
+        <p:nvSpPr>
+          <p:cNvPr id="2" name="Text 0"/>
+          <p:cNvSpPr/>
+          <p:nvPr/>
+        </p:nvSpPr>
+        <p:spPr>
+          <a:xfrm>
+            <a:off x="411480" y="146304"/>
+            <a:ext cx="11338560" cy="502920"/>
+          </a:xfrm>
+          <a:prstGeom prst="rect">
+            <a:avLst/>
+          </a:prstGeom>
+          <a:noFill/>
+          <a:ln/>
+        </p:spPr>
+        <p:txBody>
+          <a:bodyPr wrap="square" rtlCol="0" anchor="ctr"/>
+          <a:lstStyle/>
+          <a:p>
+            <a:pPr indent="0" marL="0">
+              <a:buNone/>
+            </a:pPr>
+            <a:r>
+              <a:rPr lang="en-US" sz="2400" b="1" dirty="0">
+                <a:solidFill>
+                  <a:srgbClr val="146C54"/>
+                </a:solidFill>
+                <a:latin typeface="Segoe UI" pitchFamily="34" charset="0"/>
+                <a:ea typeface="Segoe UI" pitchFamily="34" charset="-122"/>
+                <a:cs typeface="Segoe UI" pitchFamily="34" charset="-120"/>
+              </a:rPr>
+              <a:t>Verified Release: Staging to Production</a:t>
+            </a:r>
+            <a:endParaRPr lang="en-US" sz="2400" dirty="0"/>
+          </a:p>
+        </p:txBody>
+      </p:sp>
+      <p:pic>
+        <p:nvPicPr>
+          <p:cNvPr id="3" name="Image 0" descr="Verified Release: Staging to Production">    </p:cNvPr>
+          <p:cNvPicPr>
+            <a:picLocks noChangeAspect="1"/>
+          </p:cNvPicPr>
+          <p:nvPr/>
+        </p:nvPicPr>
+        <p:blipFill>
+          <a:blip r:embed="rId1"/>
+          <a:stretch>
+            <a:fillRect/>
+          </a:stretch>
+        </p:blipFill>
+        <p:spPr>
+          <a:xfrm>
+            <a:off x="2068830" y="777240"/>
+            <a:ext cx="8051292" cy="5367528"/>
+          </a:xfrm>
+          <a:prstGeom prst="rect">
+            <a:avLst/>
+          </a:prstGeom>
+        </p:spPr>
+      </p:pic>
+      <p:sp>
+        <p:nvSpPr>
+          <p:cNvPr id="4" name="Text 1"/>
+          <p:cNvSpPr/>
+          <p:nvPr/>
+        </p:nvSpPr>
+        <p:spPr>
+          <a:xfrm>
+            <a:off x="411480" y="6245352"/>
+            <a:ext cx="11338560" cy="256032"/>
+          </a:xfrm>
+          <a:prstGeom prst="rect">
+            <a:avLst/>
+          </a:prstGeom>
+          <a:noFill/>
+          <a:ln/>
+        </p:spPr>
+        <p:txBody>
+          <a:bodyPr wrap="square" rtlCol="0" anchor="ctr"/>
+          <a:lstStyle/>
+          <a:p>
+            <a:pPr indent="0" marL="0">
+              <a:buNone/>
+            </a:pPr>
+            <a:r>
+              <a:rPr lang="en-US" sz="1000" dirty="0">
+                <a:solidFill>
+                  <a:srgbClr val="53635E"/>
+                </a:solidFill>
+                <a:latin typeface="Segoe UI" pitchFamily="34" charset="0"/>
+                <a:ea typeface="Segoe UI" pitchFamily="34" charset="-122"/>
+                <a:cs typeface="Segoe UI" pitchFamily="34" charset="-120"/>
+              </a:rPr>
+              <a:t>Artifact rendering, not a portal screenshot. Synthetic fixtures. Sources and SHA-256 hashes retained.</a:t>
+            </a:r>
+            <a:endParaRPr lang="en-US" sz="1000" dirty="0"/>
+          </a:p>
+        </p:txBody>
+      </p:sp>
+      <p:sp>
+        <p:nvSpPr>
+          <p:cNvPr id="5" name="Text 2">
+            <a:hlinkClick r:id="rId2" tooltip=""/>
+          </p:cNvPr>
+          <p:cNvSpPr/>
+          <p:nvPr/>
+        </p:nvSpPr>
+        <p:spPr>
+          <a:xfrm>
+            <a:off x="411480" y="6528816"/>
+            <a:ext cx="10515600" cy="201168"/>
+          </a:xfrm>
+          <a:prstGeom prst="rect">
+            <a:avLst/>
+          </a:prstGeom>
+          <a:noFill/>
+          <a:ln/>
+        </p:spPr>
+        <p:txBody>
+          <a:bodyPr wrap="square" rtlCol="0" anchor="ctr"/>
+          <a:lstStyle/>
+          <a:p>
+            <a:pPr indent="0" marL="0">
+              <a:buNone/>
+            </a:pPr>
+            <a:r>
+              <a:rPr lang="en-US" sz="900" u="sng" dirty="0">
+                <a:solidFill>
+                  <a:srgbClr val="075C9B"/>
+                </a:solidFill>
+                <a:latin typeface="Segoe UI" pitchFamily="34" charset="0"/>
+                <a:ea typeface="Segoe UI" pitchFamily="34" charset="-122"/>
+                <a:cs typeface="Segoe UI" pitchFamily="34" charset="-120"/>
+                <a:hlinkClick r:id="rId2" invalidUrl="" action="" tgtFrame="" tooltip="" history="1" highlightClick="0" endSnd="0">
+                  <a:extLst>
+                    <a:ext uri="{A12FA001-AC4F-418D-AE19-62706E023703}">
+                      <ahyp:hlinkClr xmlns:ahyp="http://schemas.microsoft.com/office/drawing/2018/hyperlinkcolor" val="tx"/>
+                    </a:ext>
+                  </a:extLst>
+                </a:hlinkClick>
+              </a:rPr>
+              <a:t>GitHub Actions 34178081808 | f3da486 | 2026-09-08 UTC</a:t>
+            </a:r>
+            <a:endParaRPr lang="en-US" sz="900" dirty="0"/>
+          </a:p>
+        </p:txBody>
+      </p:sp>
+      <p:sp>
+        <p:nvSpPr>
+          <p:cNvPr id="7" name="Text 3"/>
+          <p:cNvSpPr/>
+          <p:nvPr/>
+        </p:nvSpPr>
+        <p:spPr>
+          <a:xfrm>
+            <a:off x="11338560" y="6528816"/>
+            <a:ext cx="548640" cy="219456"/>
+          </a:xfrm>
+          <a:prstGeom prst="rect">
+            <a:avLst/>
+          </a:prstGeom>
+          <a:noFill/>
+          <a:ln/>
+        </p:spPr>
+        <p:txBody>
+          <a:bodyPr wrap="square" rtlCol="0" anchor="ctr"/>
+          <a:lstStyle/>
+          <a:p>
+            <a:pPr algn="r" indent="0" marL="0">
+              <a:buNone/>
+            </a:pPr>
+            <a:r>
+              <a:rPr lang="en-US" sz="900" dirty="0">
+                <a:solidFill>
+                  <a:srgbClr val="767676"/>
+                </a:solidFill>
+              </a:rPr>
+              <a:t>2 / 14</a:t>
+            </a:r>
+            <a:endParaRPr lang="en-US" sz="900" dirty="0"/>
+          </a:p>
+        </p:txBody>
+      </p:sp>
+    </p:spTree>
+  </p:cSld>
+  <p:clrMapOvr>
+    <a:masterClrMapping/>
+  </p:clrMapOvr>
+</p:sld>
+</file>
+
+<file path=ppt/slides/slide3.xml><?xml version="1.0" encoding="utf-8"?>
+<p:sld xmlns:a="http://schemas.openxmlformats.org/drawingml/2006/main" xmlns:r="http://schemas.openxmlformats.org/officeDocument/2006/relationships" xmlns:p="http://schemas.openxmlformats.org/presentationml/2006/main">
+  <p:cSld name="Slide 3">
+    <p:bg>
+      <p:bgPr>
+        <a:solidFill>
+          <a:srgbClr val="FFFFFF"/>
+        </a:solidFill>
+      </p:bgPr>
+    </p:bg>
+    <p:spTree>
+      <p:nvGrpSpPr>
+        <p:cNvPr id="1" name=""/>
+        <p:cNvGrpSpPr/>
+        <p:nvPr/>
+      </p:nvGrpSpPr>
+      <p:grpSpPr>
+        <a:xfrm>
+          <a:off x="0" y="0"/>
+          <a:ext cx="0" cy="0"/>
+          <a:chOff x="0" y="0"/>
+          <a:chExt cx="0" cy="0"/>
+        </a:xfrm>
+      </p:grpSpPr>
+      <p:sp>
+        <p:nvSpPr>
+          <p:cNvPr id="2" name="Text 0"/>
+          <p:cNvSpPr/>
+          <p:nvPr/>
+        </p:nvSpPr>
+        <p:spPr>
+          <a:xfrm>
+            <a:off x="411480" y="146304"/>
+            <a:ext cx="11338560" cy="502920"/>
+          </a:xfrm>
+          <a:prstGeom prst="rect">
+            <a:avLst/>
+          </a:prstGeom>
+          <a:noFill/>
+          <a:ln/>
+        </p:spPr>
+        <p:txBody>
+          <a:bodyPr wrap="square" rtlCol="0" anchor="ctr"/>
+          <a:lstStyle/>
+          <a:p>
+            <a:pPr indent="0" marL="0">
+              <a:buNone/>
+            </a:pPr>
+            <a:r>
+              <a:rPr lang="en-US" sz="2400" b="1" dirty="0">
+                <a:solidFill>
+                  <a:srgbClr val="146C54"/>
+                </a:solidFill>
+                <a:latin typeface="Segoe UI" pitchFamily="34" charset="0"/>
+                <a:ea typeface="Segoe UI" pitchFamily="34" charset="-122"/>
+                <a:cs typeface="Segoe UI" pitchFamily="34" charset="-120"/>
+              </a:rPr>
+              <a:t>Quality Gate: 21 of 21 Judge Checks Passed</a:t>
+            </a:r>
+            <a:endParaRPr lang="en-US" sz="2400" dirty="0"/>
+          </a:p>
+        </p:txBody>
+      </p:sp>
+      <p:pic>
+        <p:nvPicPr>
+          <p:cNvPr id="3" name="Image 0" descr="Quality Gate: 21 of 21 Judge Checks Passed">    </p:cNvPr>
+          <p:cNvPicPr>
+            <a:picLocks noChangeAspect="1"/>
+          </p:cNvPicPr>
+          <p:nvPr/>
+        </p:nvPicPr>
+        <p:blipFill>
+          <a:blip r:embed="rId1"/>
+          <a:stretch>
+            <a:fillRect/>
+          </a:stretch>
+        </p:blipFill>
+        <p:spPr>
+          <a:xfrm>
+            <a:off x="2068830" y="777240"/>
+            <a:ext cx="8051292" cy="5367528"/>
+          </a:xfrm>
+          <a:prstGeom prst="rect">
+            <a:avLst/>
+          </a:prstGeom>
+        </p:spPr>
+      </p:pic>
+      <p:sp>
+        <p:nvSpPr>
+          <p:cNvPr id="4" name="Text 1"/>
+          <p:cNvSpPr/>
+          <p:nvPr/>
+        </p:nvSpPr>
+        <p:spPr>
+          <a:xfrm>
+            <a:off x="411480" y="6245352"/>
+            <a:ext cx="11338560" cy="256032"/>
+          </a:xfrm>
+          <a:prstGeom prst="rect">
+            <a:avLst/>
+          </a:prstGeom>
+          <a:noFill/>
+          <a:ln/>
+        </p:spPr>
+        <p:txBody>
+          <a:bodyPr wrap="square" rtlCol="0" anchor="ctr"/>
+          <a:lstStyle/>
+          <a:p>
+            <a:pPr indent="0" marL="0">
+              <a:buNone/>
+            </a:pPr>
+            <a:r>
+              <a:rPr lang="en-US" sz="1000" dirty="0">
+                <a:solidFill>
+                  <a:srgbClr val="53635E"/>
+                </a:solidFill>
+                <a:latin typeface="Segoe UI" pitchFamily="34" charset="0"/>
+                <a:ea typeface="Segoe UI" pitchFamily="34" charset="-122"/>
+                <a:cs typeface="Segoe UI" pitchFamily="34" charset="-120"/>
+              </a:rPr>
+              <a:t>Artifact rendering, not a portal screenshot. Synthetic fixtures. Sources and SHA-256 hashes retained.</a:t>
+            </a:r>
+            <a:endParaRPr lang="en-US" sz="1000" dirty="0"/>
+          </a:p>
+        </p:txBody>
+      </p:sp>
+      <p:sp>
+        <p:nvSpPr>
+          <p:cNvPr id="5" name="Text 2">
+            <a:hlinkClick r:id="rId2" tooltip=""/>
+          </p:cNvPr>
+          <p:cNvSpPr/>
+          <p:nvPr/>
+        </p:nvSpPr>
+        <p:spPr>
+          <a:xfrm>
+            <a:off x="411480" y="6528816"/>
+            <a:ext cx="10515600" cy="201168"/>
+          </a:xfrm>
+          <a:prstGeom prst="rect">
+            <a:avLst/>
+          </a:prstGeom>
+          <a:noFill/>
+          <a:ln/>
+        </p:spPr>
+        <p:txBody>
+          <a:bodyPr wrap="square" rtlCol="0" anchor="ctr"/>
+          <a:lstStyle/>
+          <a:p>
+            <a:pPr indent="0" marL="0">
+              <a:buNone/>
+            </a:pPr>
+            <a:r>
+              <a:rPr lang="en-US" sz="900" u="sng" dirty="0">
+                <a:solidFill>
+                  <a:srgbClr val="075C9B"/>
+                </a:solidFill>
+                <a:latin typeface="Segoe UI" pitchFamily="34" charset="0"/>
+                <a:ea typeface="Segoe UI" pitchFamily="34" charset="-122"/>
+                <a:cs typeface="Segoe UI" pitchFamily="34" charset="-120"/>
+                <a:hlinkClick r:id="rId2" invalidUrl="" action="" tgtFrame="" tooltip="" history="1" highlightClick="0" endSnd="0">
+                  <a:extLst>
+                    <a:ext uri="{A12FA001-AC4F-418D-AE19-62706E023703}">
+                      <ahyp:hlinkClr xmlns:ahyp="http://schemas.microsoft.com/office/drawing/2018/hyperlinkcolor" val="tx"/>
+                    </a:ext>
+                  </a:extLst>
+                </a:hlinkClick>
+              </a:rPr>
+              <a:t>GitHub Actions 34178081808 | f3da486 | 2026-09-08 UTC</a:t>
+            </a:r>
+            <a:endParaRPr lang="en-US" sz="900" dirty="0"/>
+          </a:p>
+        </p:txBody>
+      </p:sp>
+      <p:sp>
+        <p:nvSpPr>
+          <p:cNvPr id="7" name="Text 3"/>
+          <p:cNvSpPr/>
+          <p:nvPr/>
+        </p:nvSpPr>
+        <p:spPr>
+          <a:xfrm>
+            <a:off x="11338560" y="6528816"/>
+            <a:ext cx="548640" cy="219456"/>
+          </a:xfrm>
+          <a:prstGeom prst="rect">
+            <a:avLst/>
+          </a:prstGeom>
+          <a:noFill/>
+          <a:ln/>
+        </p:spPr>
+        <p:txBody>
+          <a:bodyPr wrap="square" rtlCol="0" anchor="ctr"/>
+          <a:lstStyle/>
+          <a:p>
+            <a:pPr algn="r" indent="0" marL="0">
+              <a:buNone/>
+            </a:pPr>
+            <a:r>
+              <a:rPr lang="en-US" sz="900" dirty="0">
+                <a:solidFill>
+                  <a:srgbClr val="767676"/>
+                </a:solidFill>
+              </a:rPr>
+              <a:t>3 / 14</a:t>
+            </a:r>
+            <a:endParaRPr lang="en-US" sz="900" dirty="0"/>
+          </a:p>
+        </p:txBody>
+      </p:sp>
+    </p:spTree>
+  </p:cSld>
+  <p:clrMapOvr>
+    <a:masterClrMapping/>
+  </p:clrMapOvr>
+</p:sld>
+</file>
+
+<file path=ppt/slides/slide4.xml><?xml version="1.0" encoding="utf-8"?>
+<p:sld xmlns:a="http://schemas.openxmlformats.org/drawingml/2006/main" xmlns:r="http://schemas.openxmlformats.org/officeDocument/2006/relationships" xmlns:p="http://schemas.openxmlformats.org/presentationml/2006/main">
+  <p:cSld name="Slide 4">
+    <p:bg>
+      <p:bgPr>
+        <a:solidFill>
+          <a:srgbClr val="FFFFFF"/>
+        </a:solidFill>
+      </p:bgPr>
+    </p:bg>
+    <p:spTree>
+      <p:nvGrpSpPr>
+        <p:cNvPr id="1" name=""/>
+        <p:cNvGrpSpPr/>
+        <p:nvPr/>
+      </p:nvGrpSpPr>
+      <p:grpSpPr>
+        <a:xfrm>
+          <a:off x="0" y="0"/>
+          <a:ext cx="0" cy="0"/>
+          <a:chOff x="0" y="0"/>
+          <a:chExt cx="0" cy="0"/>
+        </a:xfrm>
+      </p:grpSpPr>
+      <p:sp>
+        <p:nvSpPr>
+          <p:cNvPr id="2" name="Text 0"/>
+          <p:cNvSpPr/>
+          <p:nvPr/>
+        </p:nvSpPr>
+        <p:spPr>
+          <a:xfrm>
+            <a:off x="411480" y="146304"/>
+            <a:ext cx="11338560" cy="502920"/>
+          </a:xfrm>
+          <a:prstGeom prst="rect">
+            <a:avLst/>
+          </a:prstGeom>
+          <a:noFill/>
+          <a:ln/>
+        </p:spPr>
+        <p:txBody>
+          <a:bodyPr wrap="square" rtlCol="0" anchor="ctr"/>
+          <a:lstStyle/>
+          <a:p>
+            <a:pPr indent="0" marL="0">
+              <a:buNone/>
+            </a:pPr>
+            <a:r>
+              <a:rPr lang="en-US" sz="2400" b="1" dirty="0">
+                <a:solidFill>
+                  <a:srgbClr val="146C54"/>
+                </a:solidFill>
+                <a:latin typeface="Segoe UI" pitchFamily="34" charset="0"/>
+                <a:ea typeface="Segoe UI" pitchFamily="34" charset="-122"/>
+                <a:cs typeface="Segoe UI" pitchFamily="34" charset="-120"/>
+              </a:rPr>
+              <a:t>Tool Execution Proven; Telemetry Is Synthetic</a:t>
+            </a:r>
+            <a:endParaRPr lang="en-US" sz="2400" dirty="0"/>
+          </a:p>
+        </p:txBody>
+      </p:sp>
+      <p:pic>
+        <p:nvPicPr>
+          <p:cNvPr id="3" name="Image 0" descr="Tool Execution Proven; Telemetry Is Synthetic">    </p:cNvPr>
+          <p:cNvPicPr>
+            <a:picLocks noChangeAspect="1"/>
+          </p:cNvPicPr>
+          <p:nvPr/>
+        </p:nvPicPr>
+        <p:blipFill>
+          <a:blip r:embed="rId1"/>
+          <a:stretch>
+            <a:fillRect/>
+          </a:stretch>
+        </p:blipFill>
+        <p:spPr>
+          <a:xfrm>
+            <a:off x="2068830" y="777240"/>
+            <a:ext cx="8051292" cy="5367528"/>
+          </a:xfrm>
+          <a:prstGeom prst="rect">
+            <a:avLst/>
+          </a:prstGeom>
+        </p:spPr>
+      </p:pic>
+      <p:sp>
+        <p:nvSpPr>
+          <p:cNvPr id="4" name="Text 1"/>
+          <p:cNvSpPr/>
+          <p:nvPr/>
+        </p:nvSpPr>
+        <p:spPr>
+          <a:xfrm>
+            <a:off x="411480" y="6245352"/>
+            <a:ext cx="11338560" cy="256032"/>
+          </a:xfrm>
+          <a:prstGeom prst="rect">
+            <a:avLst/>
+          </a:prstGeom>
+          <a:noFill/>
+          <a:ln/>
+        </p:spPr>
+        <p:txBody>
+          <a:bodyPr wrap="square" rtlCol="0" anchor="ctr"/>
+          <a:lstStyle/>
+          <a:p>
+            <a:pPr indent="0" marL="0">
+              <a:buNone/>
+            </a:pPr>
+            <a:r>
+              <a:rPr lang="en-US" sz="1000" dirty="0">
+                <a:solidFill>
+                  <a:srgbClr val="53635E"/>
+                </a:solidFill>
+                <a:latin typeface="Segoe UI" pitchFamily="34" charset="0"/>
+                <a:ea typeface="Segoe UI" pitchFamily="34" charset="-122"/>
+                <a:cs typeface="Segoe UI" pitchFamily="34" charset="-120"/>
+              </a:rPr>
+              <a:t>Artifact rendering, not a portal screenshot. Synthetic fixtures. Sources and SHA-256 hashes retained.</a:t>
+            </a:r>
+            <a:endParaRPr lang="en-US" sz="1000" dirty="0"/>
+          </a:p>
+        </p:txBody>
+      </p:sp>
+      <p:sp>
+        <p:nvSpPr>
+          <p:cNvPr id="5" name="Text 2">
+            <a:hlinkClick r:id="rId2" tooltip=""/>
+          </p:cNvPr>
+          <p:cNvSpPr/>
+          <p:nvPr/>
+        </p:nvSpPr>
+        <p:spPr>
+          <a:xfrm>
+            <a:off x="411480" y="6528816"/>
+            <a:ext cx="10515600" cy="201168"/>
+          </a:xfrm>
+          <a:prstGeom prst="rect">
+            <a:avLst/>
+          </a:prstGeom>
+          <a:noFill/>
+          <a:ln/>
+        </p:spPr>
+        <p:txBody>
+          <a:bodyPr wrap="square" rtlCol="0" anchor="ctr"/>
+          <a:lstStyle/>
+          <a:p>
+            <a:pPr indent="0" marL="0">
+              <a:buNone/>
+            </a:pPr>
+            <a:r>
+              <a:rPr lang="en-US" sz="900" u="sng" dirty="0">
+                <a:solidFill>
+                  <a:srgbClr val="075C9B"/>
+                </a:solidFill>
+                <a:latin typeface="Segoe UI" pitchFamily="34" charset="0"/>
+                <a:ea typeface="Segoe UI" pitchFamily="34" charset="-122"/>
+                <a:cs typeface="Segoe UI" pitchFamily="34" charset="-120"/>
+                <a:hlinkClick r:id="rId2" invalidUrl="" action="" tgtFrame="" tooltip="" history="1" highlightClick="0" endSnd="0">
+                  <a:extLst>
+                    <a:ext uri="{A12FA001-AC4F-418D-AE19-62706E023703}">
+                      <ahyp:hlinkClr xmlns:ahyp="http://schemas.microsoft.com/office/drawing/2018/hyperlinkcolor" val="tx"/>
+                    </a:ext>
+                  </a:extLst>
+                </a:hlinkClick>
+              </a:rPr>
+              <a:t>GitHub Actions 34178081808 | f3da486 | 2026-09-08 UTC</a:t>
+            </a:r>
+            <a:endParaRPr lang="en-US" sz="900" dirty="0"/>
+          </a:p>
+        </p:txBody>
+      </p:sp>
+      <p:sp>
+        <p:nvSpPr>
+          <p:cNvPr id="7" name="Text 3"/>
+          <p:cNvSpPr/>
+          <p:nvPr/>
+        </p:nvSpPr>
+        <p:spPr>
+          <a:xfrm>
+            <a:off x="11338560" y="6528816"/>
+            <a:ext cx="548640" cy="219456"/>
+          </a:xfrm>
+          <a:prstGeom prst="rect">
+            <a:avLst/>
+          </a:prstGeom>
+          <a:noFill/>
+          <a:ln/>
+        </p:spPr>
+        <p:txBody>
+          <a:bodyPr wrap="square" rtlCol="0" anchor="ctr"/>
+          <a:lstStyle/>
+          <a:p>
+            <a:pPr algn="r" indent="0" marL="0">
+              <a:buNone/>
+            </a:pPr>
+            <a:r>
+              <a:rPr lang="en-US" sz="900" dirty="0">
+                <a:solidFill>
+                  <a:srgbClr val="767676"/>
+                </a:solidFill>
+              </a:rPr>
+              <a:t>4 / 14</a:t>
+            </a:r>
+            <a:endParaRPr lang="en-US" sz="900" dirty="0"/>
+          </a:p>
+        </p:txBody>
+      </p:sp>
+    </p:spTree>
+  </p:cSld>
+  <p:clrMapOvr>
+    <a:masterClrMapping/>
+  </p:clrMapOvr>
+</p:sld>
+</file>
+
+<file path=ppt/slides/slide5.xml><?xml version="1.0" encoding="utf-8"?>
+<p:sld xmlns:a="http://schemas.openxmlformats.org/drawingml/2006/main" xmlns:r="http://schemas.openxmlformats.org/officeDocument/2006/relationships" xmlns:p="http://schemas.openxmlformats.org/presentationml/2006/main">
+  <p:cSld name="Slide 5">
+    <p:bg>
+      <p:bgPr>
+        <a:solidFill>
+          <a:srgbClr val="FFFFFF"/>
+        </a:solidFill>
+      </p:bgPr>
+    </p:bg>
+    <p:spTree>
+      <p:nvGrpSpPr>
+        <p:cNvPr id="1" name=""/>
+        <p:cNvGrpSpPr/>
+        <p:nvPr/>
+      </p:nvGrpSpPr>
+      <p:grpSpPr>
+        <a:xfrm>
+          <a:off x="0" y="0"/>
+          <a:ext cx="0" cy="0"/>
+          <a:chOff x="0" y="0"/>
+          <a:chExt cx="0" cy="0"/>
+        </a:xfrm>
+      </p:grpSpPr>
+      <p:sp>
+        <p:nvSpPr>
+          <p:cNvPr id="2" name="Text 0"/>
+          <p:cNvSpPr/>
+          <p:nvPr/>
+        </p:nvSpPr>
+        <p:spPr>
+          <a:xfrm>
+            <a:off x="411480" y="146304"/>
+            <a:ext cx="11338560" cy="502920"/>
+          </a:xfrm>
+          <a:prstGeom prst="rect">
+            <a:avLst/>
+          </a:prstGeom>
+          <a:noFill/>
+          <a:ln/>
+        </p:spPr>
+        <p:txBody>
+          <a:bodyPr wrap="square" rtlCol="0" anchor="ctr"/>
+          <a:lstStyle/>
+          <a:p>
+            <a:pPr indent="0" marL="0">
+              <a:buNone/>
+            </a:pPr>
+            <a:r>
+              <a:rPr lang="en-US" sz="2400" b="1" dirty="0">
+                <a:solidFill>
+                  <a:srgbClr val="146C54"/>
+                </a:solidFill>
+                <a:latin typeface="Segoe UI" pitchFamily="34" charset="0"/>
+                <a:ea typeface="Segoe UI" pitchFamily="34" charset="-122"/>
+                <a:cs typeface="Segoe UI" pitchFamily="34" charset="-120"/>
+              </a:rPr>
+              <a:t>Production 34: Active, Smoke Test Passed</a:t>
+            </a:r>
+            <a:endParaRPr lang="en-US" sz="2400" dirty="0"/>
+          </a:p>
+        </p:txBody>
+      </p:sp>
+      <p:pic>
+        <p:nvPicPr>
+          <p:cNvPr id="3" name="Image 0" descr="Production 34: Active, Smoke Test Passed">    </p:cNvPr>
+          <p:cNvPicPr>
+            <a:picLocks noChangeAspect="1"/>
+          </p:cNvPicPr>
+          <p:nvPr/>
+        </p:nvPicPr>
+        <p:blipFill>
+          <a:blip r:embed="rId1"/>
+          <a:stretch>
+            <a:fillRect/>
+          </a:stretch>
+        </p:blipFill>
+        <p:spPr>
+          <a:xfrm>
+            <a:off x="2068830" y="777240"/>
+            <a:ext cx="8051292" cy="5367528"/>
+          </a:xfrm>
+          <a:prstGeom prst="rect">
+            <a:avLst/>
+          </a:prstGeom>
+        </p:spPr>
+      </p:pic>
+      <p:sp>
+        <p:nvSpPr>
+          <p:cNvPr id="4" name="Text 1"/>
+          <p:cNvSpPr/>
+          <p:nvPr/>
+        </p:nvSpPr>
+        <p:spPr>
+          <a:xfrm>
+            <a:off x="411480" y="6245352"/>
+            <a:ext cx="11338560" cy="256032"/>
+          </a:xfrm>
+          <a:prstGeom prst="rect">
+            <a:avLst/>
+          </a:prstGeom>
+          <a:noFill/>
+          <a:ln/>
+        </p:spPr>
+        <p:txBody>
+          <a:bodyPr wrap="square" rtlCol="0" anchor="ctr"/>
+          <a:lstStyle/>
+          <a:p>
+            <a:pPr indent="0" marL="0">
+              <a:buNone/>
+            </a:pPr>
+            <a:r>
+              <a:rPr lang="en-US" sz="1000" dirty="0">
+                <a:solidFill>
+                  <a:srgbClr val="53635E"/>
+                </a:solidFill>
+                <a:latin typeface="Segoe UI" pitchFamily="34" charset="0"/>
+                <a:ea typeface="Segoe UI" pitchFamily="34" charset="-122"/>
+                <a:cs typeface="Segoe UI" pitchFamily="34" charset="-120"/>
+              </a:rPr>
+              <a:t>Artifact rendering, not a portal screenshot. Synthetic fixtures. Sources and SHA-256 hashes retained.</a:t>
+            </a:r>
+            <a:endParaRPr lang="en-US" sz="1000" dirty="0"/>
+          </a:p>
+        </p:txBody>
+      </p:sp>
+      <p:sp>
+        <p:nvSpPr>
+          <p:cNvPr id="5" name="Text 2">
+            <a:hlinkClick r:id="rId2" tooltip=""/>
+          </p:cNvPr>
+          <p:cNvSpPr/>
+          <p:nvPr/>
+        </p:nvSpPr>
+        <p:spPr>
+          <a:xfrm>
+            <a:off x="411480" y="6528816"/>
+            <a:ext cx="10515600" cy="201168"/>
+          </a:xfrm>
+          <a:prstGeom prst="rect">
+            <a:avLst/>
+          </a:prstGeom>
+          <a:noFill/>
+          <a:ln/>
+        </p:spPr>
+        <p:txBody>
+          <a:bodyPr wrap="square" rtlCol="0" anchor="ctr"/>
+          <a:lstStyle/>
+          <a:p>
+            <a:pPr indent="0" marL="0">
+              <a:buNone/>
+            </a:pPr>
+            <a:r>
+              <a:rPr lang="en-US" sz="900" u="sng" dirty="0">
+                <a:solidFill>
+                  <a:srgbClr val="075C9B"/>
+                </a:solidFill>
+                <a:latin typeface="Segoe UI" pitchFamily="34" charset="0"/>
+                <a:ea typeface="Segoe UI" pitchFamily="34" charset="-122"/>
+                <a:cs typeface="Segoe UI" pitchFamily="34" charset="-120"/>
+                <a:hlinkClick r:id="rId2" invalidUrl="" action="" tgtFrame="" tooltip="" history="1" highlightClick="0" endSnd="0">
+                  <a:extLst>
+                    <a:ext uri="{A12FA001-AC4F-418D-AE19-62706E023703}">
+                      <ahyp:hlinkClr xmlns:ahyp="http://schemas.microsoft.com/office/drawing/2018/hyperlinkcolor" val="tx"/>
+                    </a:ext>
+                  </a:extLst>
+                </a:hlinkClick>
+              </a:rPr>
+              <a:t>GitHub Actions 34178081808 | f3da486 | 2026-09-08 UTC</a:t>
+            </a:r>
+            <a:endParaRPr lang="en-US" sz="900" dirty="0"/>
+          </a:p>
+        </p:txBody>
+      </p:sp>
+      <p:sp>
+        <p:nvSpPr>
+          <p:cNvPr id="7" name="Text 3"/>
+          <p:cNvSpPr/>
+          <p:nvPr/>
+        </p:nvSpPr>
+        <p:spPr>
+          <a:xfrm>
+            <a:off x="11338560" y="6528816"/>
+            <a:ext cx="548640" cy="219456"/>
+          </a:xfrm>
+          <a:prstGeom prst="rect">
+            <a:avLst/>
+          </a:prstGeom>
+          <a:noFill/>
+          <a:ln/>
+        </p:spPr>
+        <p:txBody>
+          <a:bodyPr wrap="square" rtlCol="0" anchor="ctr"/>
+          <a:lstStyle/>
+          <a:p>
+            <a:pPr algn="r" indent="0" marL="0">
+              <a:buNone/>
+            </a:pPr>
+            <a:r>
+              <a:rPr lang="en-US" sz="900" dirty="0">
+                <a:solidFill>
+                  <a:srgbClr val="767676"/>
+                </a:solidFill>
+              </a:rPr>
+              <a:t>5 / 14</a:t>
             </a:r>
             <a:endParaRPr lang="en-US" sz="900" dirty="0"/>
           </a:p>
@@ -3691,7 +5101,7 @@
                 <a:ea typeface="Segoe UI" pitchFamily="34" charset="-122"/>
                 <a:cs typeface="Segoe UI" pitchFamily="34" charset="-120"/>
               </a:rPr>
-              <a:t>EVALUATION</a:t>
+              <a:t>AGENDA</a:t>
             </a:r>
             <a:endParaRPr lang="en-US" sz="1100" dirty="0"/>
           </a:p>
@@ -3730,7 +5140,7 @@
                 <a:ea typeface="Segoe UI" pitchFamily="34" charset="-122"/>
                 <a:cs typeface="Segoe UI" pitchFamily="34" charset="-120"/>
               </a:rPr>
-              <a:t>Deterministic Checks + LLM-as-Judge Rubrics</a:t>
+              <a:t>Nine Labs, One Real Deployment</a:t>
             </a:r>
             <a:endParaRPr lang="en-US" sz="2600" dirty="0"/>
           </a:p>
@@ -3793,8 +5203,7 @@
                 <a:ea typeface="Segoe UI" pitchFamily="34" charset="-122"/>
                 <a:cs typeface="Segoe UI" pitchFamily="34" charset="-120"/>
               </a:rPr>
-              <a:t>Golden dataset: 8 categories (true/false positive, ambiguous, missing data, conflicting tools, prompt injection, unauthorized actions, unsupported conclusions)
-</a:t>
+              <a:t>Lab 00 — Prerequisites and environment setup</a:t>
             </a:r>
             <a:endParaRPr lang="en-US" sz="1500" dirty="0"/>
           </a:p>
@@ -3815,8 +5224,7 @@
                 <a:ea typeface="Segoe UI" pitchFamily="34" charset="-122"/>
                 <a:cs typeface="Segoe UI" pitchFamily="34" charset="-120"/>
               </a:rPr>
-              <a:t>Deterministic: schema validity, required citations, allowed tool calls, policy constraints — fast, reproducible
-</a:t>
+              <a:t>Lab 01 — Architecture deep dive (LangGraph supervisor/specialists)</a:t>
             </a:r>
             <a:endParaRPr lang="en-US" sz="1500" dirty="0"/>
           </a:p>
@@ -3837,8 +5245,7 @@
                 <a:ea typeface="Segoe UI" pitchFamily="34" charset="-122"/>
                 <a:cs typeface="Segoe UI" pitchFamily="34" charset="-120"/>
               </a:rPr>
-              <a:t>Built-in Foundry evaluators first: coherence, groundedness, task adherence, tool-call accuracy
-</a:t>
+              <a:t>Lab 02 — Deploy the MCP tool servers</a:t>
             </a:r>
             <a:endParaRPr lang="en-US" sz="1500" dirty="0"/>
           </a:p>
@@ -3859,8 +5266,7 @@
                 <a:ea typeface="Segoe UI" pitchFamily="34" charset="-122"/>
                 <a:cs typeface="Segoe UI" pitchFamily="34" charset="-120"/>
               </a:rPr>
-              <a:t>Custom rubrics only where the catalog doesn’t reach: triage correctness, citation quality, conflict handling
-</a:t>
+              <a:t>Lab 03 — Provision and deploy the hosted agent (azd)</a:t>
             </a:r>
             <a:endParaRPr lang="en-US" sz="1500" dirty="0"/>
           </a:p>
@@ -3881,16 +5287,99 @@
                 <a:ea typeface="Segoe UI" pitchFamily="34" charset="-122"/>
                 <a:cs typeface="Segoe UI" pitchFamily="34" charset="-120"/>
               </a:rPr>
-              <a:t>Policy rules (e.g. never claim an unauthorized remediation action) stay deterministic, not LLM-judged
-</a:t>
+              <a:t>Lab 04 — Invoke the agent and read traces</a:t>
             </a:r>
             <a:endParaRPr lang="en-US" sz="1500" dirty="0"/>
           </a:p>
-        </p:txBody>
-      </p:sp>
-      <p:sp>
-        <p:nvSpPr>
-          <p:cNvPr id="7" name="Shape 5"/>
+          <a:p>
+            <a:pPr marL="254000" indent="-254000">
+              <a:lnSpc>
+                <a:spcPct val="125000"/>
+              </a:lnSpc>
+              <a:buSzPct val="100000"/>
+              <a:buChar char="●"/>
+            </a:pPr>
+            <a:r>
+              <a:rPr lang="en-US" sz="1500" dirty="0">
+                <a:solidFill>
+                  <a:srgbClr val="1A1A1A"/>
+                </a:solidFill>
+                <a:latin typeface="Segoe UI" pitchFamily="34" charset="0"/>
+                <a:ea typeface="Segoe UI" pitchFamily="34" charset="-122"/>
+                <a:cs typeface="Segoe UI" pitchFamily="34" charset="-120"/>
+              </a:rPr>
+              <a:t>Lab 05 — Evaluations: deterministic + LLM-as-judge</a:t>
+            </a:r>
+            <a:endParaRPr lang="en-US" sz="1500" dirty="0"/>
+          </a:p>
+          <a:p>
+            <a:pPr marL="254000" indent="-254000">
+              <a:lnSpc>
+                <a:spcPct val="125000"/>
+              </a:lnSpc>
+              <a:buSzPct val="100000"/>
+              <a:buChar char="●"/>
+            </a:pPr>
+            <a:r>
+              <a:rPr lang="en-US" sz="1500" dirty="0">
+                <a:solidFill>
+                  <a:srgbClr val="1A1A1A"/>
+                </a:solidFill>
+                <a:latin typeface="Segoe UI" pitchFamily="34" charset="0"/>
+                <a:ea typeface="Segoe UI" pitchFamily="34" charset="-122"/>
+                <a:cs typeface="Segoe UI" pitchFamily="34" charset="-120"/>
+              </a:rPr>
+              <a:t>Lab 06 — CI/CD: evaluation-gated release pipeline</a:t>
+            </a:r>
+            <a:endParaRPr lang="en-US" sz="1500" dirty="0"/>
+          </a:p>
+          <a:p>
+            <a:pPr marL="254000" indent="-254000">
+              <a:lnSpc>
+                <a:spcPct val="125000"/>
+              </a:lnSpc>
+              <a:buSzPct val="100000"/>
+              <a:buChar char="●"/>
+            </a:pPr>
+            <a:r>
+              <a:rPr lang="en-US" sz="1500" dirty="0">
+                <a:solidFill>
+                  <a:srgbClr val="1A1A1A"/>
+                </a:solidFill>
+                <a:latin typeface="Segoe UI" pitchFamily="34" charset="0"/>
+                <a:ea typeface="Segoe UI" pitchFamily="34" charset="-122"/>
+                <a:cs typeface="Segoe UI" pitchFamily="34" charset="-120"/>
+              </a:rPr>
+              <a:t>Lab 07 — Real-world troubleshooting: RBAC 401</a:t>
+            </a:r>
+            <a:endParaRPr lang="en-US" sz="1500" dirty="0"/>
+          </a:p>
+          <a:p>
+            <a:pPr marL="254000" indent="-254000">
+              <a:lnSpc>
+                <a:spcPct val="125000"/>
+              </a:lnSpc>
+              <a:buSzPct val="100000"/>
+              <a:buChar char="●"/>
+            </a:pPr>
+            <a:r>
+              <a:rPr lang="en-US" sz="1500" dirty="0">
+                <a:solidFill>
+                  <a:srgbClr val="1A1A1A"/>
+                </a:solidFill>
+                <a:latin typeface="Segoe UI" pitchFamily="34" charset="0"/>
+                <a:ea typeface="Segoe UI" pitchFamily="34" charset="-122"/>
+                <a:cs typeface="Segoe UI" pitchFamily="34" charset="-120"/>
+              </a:rPr>
+              <a:t>Lab 08 — Production readiness and decision gates</a:t>
+            </a:r>
+            <a:endParaRPr lang="en-US" sz="1500" dirty="0"/>
+          </a:p>
+        </p:txBody>
+      </p:sp>
+      <p:sp>
+        <p:nvSpPr>
+          <p:cNvPr id="8" name="Shape 5"/>
           <p:cNvSpPr/>
           <p:nvPr/>
         </p:nvSpPr>
@@ -3910,7 +5399,7 @@
       </p:sp>
       <p:sp>
         <p:nvSpPr>
-          <p:cNvPr id="8" name="Text 6"/>
+          <p:cNvPr id="9" name="Text 6"/>
           <p:cNvSpPr/>
           <p:nvPr/>
         </p:nvSpPr>
@@ -3941,7 +5430,43 @@
                 <a:ea typeface="Segoe UI" pitchFamily="34" charset="-122"/>
                 <a:cs typeface="Segoe UI" pitchFamily="34" charset="-120"/>
               </a:rPr>
-              <a:t>Foundry Hosted Agents Workshop — 5 / 9</a:t>
+              <a:t>Foundry Hosted Agents Workshop</a:t>
+            </a:r>
+            <a:endParaRPr lang="en-US" sz="900" dirty="0"/>
+          </a:p>
+        </p:txBody>
+      </p:sp>
+      <p:sp>
+        <p:nvSpPr>
+          <p:cNvPr id="10" name="Text 7"/>
+          <p:cNvSpPr/>
+          <p:nvPr/>
+        </p:nvSpPr>
+        <p:spPr>
+          <a:xfrm>
+            <a:off x="11338560" y="6528816"/>
+            <a:ext cx="548640" cy="219456"/>
+          </a:xfrm>
+          <a:prstGeom prst="rect">
+            <a:avLst/>
+          </a:prstGeom>
+          <a:noFill/>
+          <a:ln/>
+        </p:spPr>
+        <p:txBody>
+          <a:bodyPr wrap="square" rtlCol="0" anchor="ctr"/>
+          <a:lstStyle/>
+          <a:p>
+            <a:pPr algn="r" indent="0" marL="0">
+              <a:buNone/>
+            </a:pPr>
+            <a:r>
+              <a:rPr lang="en-US" sz="900" dirty="0">
+                <a:solidFill>
+                  <a:srgbClr val="767676"/>
+                </a:solidFill>
+              </a:rPr>
+              <a:t>6 / 14</a:t>
             </a:r>
             <a:endParaRPr lang="en-US" sz="900" dirty="0"/>
           </a:p>
@@ -4032,7 +5557,7 @@
                 <a:ea typeface="Segoe UI" pitchFamily="34" charset="-122"/>
                 <a:cs typeface="Segoe UI" pitchFamily="34" charset="-120"/>
               </a:rPr>
-              <a:t>CI/CD</a:t>
+              <a:t>ARCHITECTURE</a:t>
             </a:r>
             <a:endParaRPr lang="en-US" sz="1100" dirty="0"/>
           </a:p>
@@ -4071,7 +5596,7 @@
                 <a:ea typeface="Segoe UI" pitchFamily="34" charset="-122"/>
                 <a:cs typeface="Segoe UI" pitchFamily="34" charset="-120"/>
               </a:rPr>
-              <a:t>Evaluation-Gated Release Pipeline</a:t>
+              <a:t>Supervisor + Specialist Graph</a:t>
             </a:r>
             <a:endParaRPr lang="en-US" sz="2600" dirty="0"/>
           </a:p>
@@ -4134,8 +5659,7 @@
                 <a:ea typeface="Segoe UI" pitchFamily="34" charset="-122"/>
                 <a:cs typeface="Segoe UI" pitchFamily="34" charset="-120"/>
               </a:rPr>
-              <a:t>Two pipelines: hosted-agent-cd.yml (direct to shared PoC env) and deploy-and-evaluate.yml (full staging → production flow)
-</a:t>
+              <a:t>A LangGraph supervisor routes to three specialist nodes: Evidence Investigator, Risk Analyst, Report Composer</a:t>
             </a:r>
             <a:endParaRPr lang="en-US" sz="1500" dirty="0"/>
           </a:p>
@@ -4156,8 +5680,7 @@
                 <a:ea typeface="Segoe UI" pitchFamily="34" charset="-122"/>
                 <a:cs typeface="Segoe UI" pitchFamily="34" charset="-120"/>
               </a:rPr>
-              <a:t>Full flow: lint/tests → Bicep validate → deploy immutable candidate to staging → smoke/contract/streaming tests
-</a:t>
+              <a:t>Each specialist has its own prompt, tool permissions, and evaluation criteria</a:t>
             </a:r>
             <a:endParaRPr lang="en-US" sz="1500" dirty="0"/>
           </a:p>
@@ -4178,8 +5701,7 @@
                 <a:ea typeface="Segoe UI" pitchFamily="34" charset="-122"/>
                 <a:cs typeface="Segoe UI" pitchFamily="34" charset="-120"/>
               </a:rPr>
-              <a:t>Offline evaluation quality gate runs against the staging candidate before any manual production approval
-</a:t>
+              <a:t>Tool isolation by role: Evidence Investigator → defender-conn only, Risk Analyst → anomaly-conn only</a:t>
             </a:r>
             <a:endParaRPr lang="en-US" sz="1500" dirty="0"/>
           </a:p>
@@ -4200,8 +5722,7 @@
                 <a:ea typeface="Segoe UI" pitchFamily="34" charset="-122"/>
                 <a:cs typeface="Segoe UI" pitchFamily="34" charset="-120"/>
               </a:rPr>
-              <a:t>Secretless OIDC federation — no stored client secrets in either pipeline
-</a:t>
+              <a:t>The Report Composer has zero tool access — it only synthesizes</a:t>
             </a:r>
             <a:endParaRPr lang="en-US" sz="1500" dirty="0"/>
           </a:p>
@@ -4222,8 +5743,7 @@
                 <a:ea typeface="Segoe UI" pitchFamily="34" charset="-122"/>
                 <a:cs typeface="Segoe UI" pitchFamily="34" charset="-120"/>
               </a:rPr>
-              <a:t>Lesson learned: auto-firing both pipelines on every push raced against the same shared resource — now manual-dispatch only
-</a:t>
+              <a:t>Supported versioned MCP transport, fresh Entra tokens and RemoteTool connections now work; runtime receipts prove specialist tool execution</a:t>
             </a:r>
             <a:endParaRPr lang="en-US" sz="1500" dirty="0"/>
           </a:p>
@@ -4231,7 +5751,7 @@
       </p:sp>
       <p:sp>
         <p:nvSpPr>
-          <p:cNvPr id="7" name="Shape 5"/>
+          <p:cNvPr id="8" name="Shape 5"/>
           <p:cNvSpPr/>
           <p:nvPr/>
         </p:nvSpPr>
@@ -4251,7 +5771,7 @@
       </p:sp>
       <p:sp>
         <p:nvSpPr>
-          <p:cNvPr id="8" name="Text 6"/>
+          <p:cNvPr id="9" name="Text 6"/>
           <p:cNvSpPr/>
           <p:nvPr/>
         </p:nvSpPr>
@@ -4282,7 +5802,43 @@
                 <a:ea typeface="Segoe UI" pitchFamily="34" charset="-122"/>
                 <a:cs typeface="Segoe UI" pitchFamily="34" charset="-120"/>
               </a:rPr>
-              <a:t>Foundry Hosted Agents Workshop — 6 / 9</a:t>
+              <a:t>Foundry Hosted Agents Workshop</a:t>
+            </a:r>
+            <a:endParaRPr lang="en-US" sz="900" dirty="0"/>
+          </a:p>
+        </p:txBody>
+      </p:sp>
+      <p:sp>
+        <p:nvSpPr>
+          <p:cNvPr id="10" name="Text 7"/>
+          <p:cNvSpPr/>
+          <p:nvPr/>
+        </p:nvSpPr>
+        <p:spPr>
+          <a:xfrm>
+            <a:off x="11338560" y="6528816"/>
+            <a:ext cx="548640" cy="219456"/>
+          </a:xfrm>
+          <a:prstGeom prst="rect">
+            <a:avLst/>
+          </a:prstGeom>
+          <a:noFill/>
+          <a:ln/>
+        </p:spPr>
+        <p:txBody>
+          <a:bodyPr wrap="square" rtlCol="0" anchor="ctr"/>
+          <a:lstStyle/>
+          <a:p>
+            <a:pPr algn="r" indent="0" marL="0">
+              <a:buNone/>
+            </a:pPr>
+            <a:r>
+              <a:rPr lang="en-US" sz="900" dirty="0">
+                <a:solidFill>
+                  <a:srgbClr val="767676"/>
+                </a:solidFill>
+              </a:rPr>
+              <a:t>7 / 14</a:t>
             </a:r>
             <a:endParaRPr lang="en-US" sz="900" dirty="0"/>
           </a:p>
@@ -4335,7 +5891,7 @@
             <a:avLst/>
           </a:prstGeom>
           <a:solidFill>
-            <a:srgbClr val="D13438"/>
+            <a:srgbClr val="0078D4"/>
           </a:solidFill>
           <a:ln/>
         </p:spPr>
@@ -4367,13 +5923,13 @@
             <a:r>
               <a:rPr lang="en-US" sz="1100" b="1" spc="100" kern="0" dirty="0">
                 <a:solidFill>
-                  <a:srgbClr val="D13438"/>
-                </a:solidFill>
-                <a:latin typeface="Segoe UI" pitchFamily="34" charset="0"/>
-                <a:ea typeface="Segoe UI" pitchFamily="34" charset="-122"/>
-                <a:cs typeface="Segoe UI" pitchFamily="34" charset="-120"/>
-              </a:rPr>
-              <a:t>REAL-WORLD TROUBLESHOOTING</a:t>
+                  <a:srgbClr val="0078D4"/>
+                </a:solidFill>
+                <a:latin typeface="Segoe UI" pitchFamily="34" charset="0"/>
+                <a:ea typeface="Segoe UI" pitchFamily="34" charset="-122"/>
+                <a:cs typeface="Segoe UI" pitchFamily="34" charset="-120"/>
+              </a:rPr>
+              <a:t>TOOLS</a:t>
             </a:r>
             <a:endParaRPr lang="en-US" sz="1100" dirty="0"/>
           </a:p>
@@ -4412,7 +5968,7 @@
                 <a:ea typeface="Segoe UI" pitchFamily="34" charset="-122"/>
                 <a:cs typeface="Segoe UI" pitchFamily="34" charset="-120"/>
               </a:rPr>
-              <a:t>Diagnosing a Live RBAC 401 (Still Open)</a:t>
+              <a:t>Four Layers: Implement, Host, Register, Consume</a:t>
             </a:r>
             <a:endParaRPr lang="en-US" sz="2600" dirty="0"/>
           </a:p>
@@ -4475,8 +6031,7 @@
                 <a:ea typeface="Segoe UI" pitchFamily="34" charset="-122"/>
                 <a:cs typeface="Segoe UI" pitchFamily="34" charset="-120"/>
               </a:rPr>
-              <a:t>Symptom: 401 PermissionDenied on Azure OpenAI chat completions from the hosted agent’s own Instance Identity
-</a:t>
+              <a:t>Layer 1 — Implementation: custom MCP server code (Defender tools, anomaly tools)</a:t>
             </a:r>
             <a:endParaRPr lang="en-US" sz="1500" dirty="0"/>
           </a:p>
@@ -4497,8 +6052,7 @@
                 <a:ea typeface="Segoe UI" pitchFamily="34" charset="-122"/>
                 <a:cs typeface="Segoe UI" pitchFamily="34" charset="-120"/>
               </a:rPr>
-              <a:t>Don’t trust the error message’s own diagnosis — verify the role assignment directly with az role assignment list
-</a:t>
+              <a:t>Layer 2 — Hosting: independent Azure Container Apps, own auth/networking/health checks</a:t>
             </a:r>
             <a:endParaRPr lang="en-US" sz="1500" dirty="0"/>
           </a:p>
@@ -4519,8 +6073,7 @@
                 <a:ea typeface="Segoe UI" pitchFamily="34" charset="-122"/>
                 <a:cs typeface="Segoe UI" pitchFamily="34" charset="-120"/>
               </a:rPr>
-              <a:t>Read the built-in role’s dataActions from az role definition list — proves the role does cover the exact data action
-</a:t>
+              <a:t>Layer 3 — Registration: Foundry connections define endpoint + credential policy per MCP server</a:t>
             </a:r>
             <a:endParaRPr lang="en-US" sz="1500" dirty="0"/>
           </a:p>
@@ -4541,8 +6094,7 @@
                 <a:ea typeface="Segoe UI" pitchFamily="34" charset="-122"/>
                 <a:cs typeface="Segoe UI" pitchFamily="34" charset="-120"/>
               </a:rPr>
-              <a:t>Check disableLocalAuth, networkAcls, and Azure Policy state to rule out silent overrides
-</a:t>
+              <a:t>Layer 4 — Consumption: Foundry Toolbox aggregates registered tools for reuse across agents</a:t>
             </a:r>
             <a:endParaRPr lang="en-US" sz="1500" dirty="0"/>
           </a:p>
@@ -4563,38 +6115,15 @@
                 <a:ea typeface="Segoe UI" pitchFamily="34" charset="-122"/>
                 <a:cs typeface="Segoe UI" pitchFamily="34" charset="-120"/>
               </a:rPr>
-              <a:t>Enumerate tenant Conditional Access policies for service-principal-targeted conditions
-</a:t>
+              <a:t>The Toolbox is the registration/aggregation layer — not the hosting runtime for your MCP code</a:t>
             </a:r>
             <a:endParaRPr lang="en-US" sz="1500" dirty="0"/>
           </a:p>
-          <a:p>
-            <a:pPr marL="254000" indent="-254000">
-              <a:lnSpc>
-                <a:spcPct val="125000"/>
-              </a:lnSpc>
-              <a:buSzPct val="100000"/>
-              <a:buChar char="●"/>
-            </a:pPr>
-            <a:r>
-              <a:rPr lang="en-US" sz="1500" dirty="0">
-                <a:solidFill>
-                  <a:srgbClr val="1A1A1A"/>
-                </a:solidFill>
-                <a:latin typeface="Segoe UI" pitchFamily="34" charset="0"/>
-                <a:ea typeface="Segoe UI" pitchFamily="34" charset="-122"/>
-                <a:cs typeface="Segoe UI" pitchFamily="34" charset="-120"/>
-              </a:rPr>
-              <a:t>A working manual-agent path next to a failing hosted-agent path points at the platform, not customer-side RBAC
-</a:t>
-            </a:r>
-            <a:endParaRPr lang="en-US" sz="1500" dirty="0"/>
-          </a:p>
-        </p:txBody>
-      </p:sp>
-      <p:sp>
-        <p:nvSpPr>
-          <p:cNvPr id="7" name="Shape 5"/>
+        </p:txBody>
+      </p:sp>
+      <p:sp>
+        <p:nvSpPr>
+          <p:cNvPr id="8" name="Shape 5"/>
           <p:cNvSpPr/>
           <p:nvPr/>
         </p:nvSpPr>
@@ -4614,7 +6143,7 @@
       </p:sp>
       <p:sp>
         <p:nvSpPr>
-          <p:cNvPr id="8" name="Text 6"/>
+          <p:cNvPr id="9" name="Text 6"/>
           <p:cNvSpPr/>
           <p:nvPr/>
         </p:nvSpPr>
@@ -4645,7 +6174,43 @@
                 <a:ea typeface="Segoe UI" pitchFamily="34" charset="-122"/>
                 <a:cs typeface="Segoe UI" pitchFamily="34" charset="-120"/>
               </a:rPr>
-              <a:t>Foundry Hosted Agents Workshop — 7 / 9</a:t>
+              <a:t>Foundry Hosted Agents Workshop</a:t>
+            </a:r>
+            <a:endParaRPr lang="en-US" sz="900" dirty="0"/>
+          </a:p>
+        </p:txBody>
+      </p:sp>
+      <p:sp>
+        <p:nvSpPr>
+          <p:cNvPr id="10" name="Text 7"/>
+          <p:cNvSpPr/>
+          <p:nvPr/>
+        </p:nvSpPr>
+        <p:spPr>
+          <a:xfrm>
+            <a:off x="11338560" y="6528816"/>
+            <a:ext cx="548640" cy="219456"/>
+          </a:xfrm>
+          <a:prstGeom prst="rect">
+            <a:avLst/>
+          </a:prstGeom>
+          <a:noFill/>
+          <a:ln/>
+        </p:spPr>
+        <p:txBody>
+          <a:bodyPr wrap="square" rtlCol="0" anchor="ctr"/>
+          <a:lstStyle/>
+          <a:p>
+            <a:pPr algn="r" indent="0" marL="0">
+              <a:buNone/>
+            </a:pPr>
+            <a:r>
+              <a:rPr lang="en-US" sz="900" dirty="0">
+                <a:solidFill>
+                  <a:srgbClr val="767676"/>
+                </a:solidFill>
+              </a:rPr>
+              <a:t>8 / 14</a:t>
             </a:r>
             <a:endParaRPr lang="en-US" sz="900" dirty="0"/>
           </a:p>
@@ -4736,7 +6301,7 @@
                 <a:ea typeface="Segoe UI" pitchFamily="34" charset="-122"/>
                 <a:cs typeface="Segoe UI" pitchFamily="34" charset="-120"/>
               </a:rPr>
-              <a:t>PRODUCTION READINESS</a:t>
+              <a:t>DEPLOYMENT</a:t>
             </a:r>
             <a:endParaRPr lang="en-US" sz="1100" dirty="0"/>
           </a:p>
@@ -4775,7 +6340,7 @@
                 <a:ea typeface="Segoe UI" pitchFamily="34" charset="-122"/>
                 <a:cs typeface="Segoe UI" pitchFamily="34" charset="-120"/>
               </a:rPr>
-              <a:t>Honest Gates, Not False Confidence</a:t>
+              <a:t>One Manifest: azure.yaml + azd</a:t>
             </a:r>
             <a:endParaRPr lang="en-US" sz="2600" dirty="0"/>
           </a:p>
@@ -4838,8 +6403,7 @@
                 <a:ea typeface="Segoe UI" pitchFamily="34" charset="-122"/>
                 <a:cs typeface="Segoe UI" pitchFamily="34" charset="-120"/>
               </a:rPr>
-              <a:t>Four experiment tracks: load testing, Cosmos DB checkpointer, Agent 365 onboarding, continuous evaluation
-</a:t>
+              <a:t>azure.yaml wires the Foundry project, model deployment, Toolbox connections, and the hosted agent service</a:t>
             </a:r>
             <a:endParaRPr lang="en-US" sz="1500" dirty="0"/>
           </a:p>
@@ -4860,8 +6424,7 @@
                 <a:ea typeface="Segoe UI" pitchFamily="34" charset="-122"/>
                 <a:cs typeface="Segoe UI" pitchFamily="34" charset="-120"/>
               </a:rPr>
-              <a:t>Quality gate: Pass — golden dataset + 12/12 deterministic checks + rubric mapping
-</a:t>
+              <a:t>kind: hosted — Foundry operates the session compute; you own only the graph code</a:t>
             </a:r>
             <a:endParaRPr lang="en-US" sz="1500" dirty="0"/>
           </a:p>
@@ -4882,8 +6445,7 @@
                 <a:ea typeface="Segoe UI" pitchFamily="34" charset="-122"/>
                 <a:cs typeface="Segoe UI" pitchFamily="34" charset="-120"/>
               </a:rPr>
-              <a:t>Scale, Security, Operations gates: Conditional — partial evidence, named follow-ups
-</a:t>
+              <a:t>dependencyResolution: remote_build — Foundry builds your Python dependencies server-side</a:t>
             </a:r>
             <a:endParaRPr lang="en-US" sz="1500" dirty="0"/>
           </a:p>
@@ -4904,8 +6466,7 @@
                 <a:ea typeface="Segoe UI" pitchFamily="34" charset="-122"/>
                 <a:cs typeface="Segoe UI" pitchFamily="34" charset="-120"/>
               </a:rPr>
-              <a:t>Platform status, Data, Cost gates: Not testable in this PoC — require commercial/legal/platform confirmation
-</a:t>
+              <a:t>protocol: responses — OpenAI-compatible Responses protocol with streaming support</a:t>
             </a:r>
             <a:endParaRPr lang="en-US" sz="1500" dirty="0"/>
           </a:p>
@@ -4926,8 +6487,7 @@
                 <a:ea typeface="Segoe UI" pitchFamily="34" charset="-122"/>
                 <a:cs typeface="Segoe UI" pitchFamily="34" charset="-120"/>
               </a:rPr>
-              <a:t>Overall recommendation: conditional go for continued PoC-to-pilot investment, not an unconditional yes/no
-</a:t>
+              <a:t>azd provision creates infrastructure; azd deploy publishes a new agent version — separate lifecycles</a:t>
             </a:r>
             <a:endParaRPr lang="en-US" sz="1500" dirty="0"/>
           </a:p>
@@ -4935,7 +6495,7 @@
       </p:sp>
       <p:sp>
         <p:nvSpPr>
-          <p:cNvPr id="7" name="Shape 5"/>
+          <p:cNvPr id="8" name="Shape 5"/>
           <p:cNvSpPr/>
           <p:nvPr/>
         </p:nvSpPr>
@@ -4955,7 +6515,7 @@
       </p:sp>
       <p:sp>
         <p:nvSpPr>
-          <p:cNvPr id="8" name="Text 6"/>
+          <p:cNvPr id="9" name="Text 6"/>
           <p:cNvSpPr/>
           <p:nvPr/>
         </p:nvSpPr>
@@ -4986,7 +6546,43 @@
                 <a:ea typeface="Segoe UI" pitchFamily="34" charset="-122"/>
                 <a:cs typeface="Segoe UI" pitchFamily="34" charset="-120"/>
               </a:rPr>
-              <a:t>Foundry Hosted Agents Workshop — 8 / 9</a:t>
+              <a:t>Foundry Hosted Agents Workshop</a:t>
+            </a:r>
+            <a:endParaRPr lang="en-US" sz="900" dirty="0"/>
+          </a:p>
+        </p:txBody>
+      </p:sp>
+      <p:sp>
+        <p:nvSpPr>
+          <p:cNvPr id="10" name="Text 7"/>
+          <p:cNvSpPr/>
+          <p:nvPr/>
+        </p:nvSpPr>
+        <p:spPr>
+          <a:xfrm>
+            <a:off x="11338560" y="6528816"/>
+            <a:ext cx="548640" cy="219456"/>
+          </a:xfrm>
+          <a:prstGeom prst="rect">
+            <a:avLst/>
+          </a:prstGeom>
+          <a:noFill/>
+          <a:ln/>
+        </p:spPr>
+        <p:txBody>
+          <a:bodyPr wrap="square" rtlCol="0" anchor="ctr"/>
+          <a:lstStyle/>
+          <a:p>
+            <a:pPr algn="r" indent="0" marL="0">
+              <a:buNone/>
+            </a:pPr>
+            <a:r>
+              <a:rPr lang="en-US" sz="900" dirty="0">
+                <a:solidFill>
+                  <a:srgbClr val="767676"/>
+                </a:solidFill>
+              </a:rPr>
+              <a:t>9 / 14</a:t>
             </a:r>
             <a:endParaRPr lang="en-US" sz="900" dirty="0"/>
           </a:p>

</xml_diff>